<commit_message>
feat: render datadog-cowork-plugin revision 04 with four voices
- master all variants to -16 LUFS with anti-imaging resampling
- archive the previous release locally and refresh analysis and Office QA

🎙️ - Generated by Copilot

Co-authored-by: Copilot <223556219+Copilot@users.noreply.github.com>
</commit_message>
<xml_diff>
--- a/projects/datadog-cowork-plugin/release/outputs/deck.pptx
+++ b/projects/datadog-cowork-plugin/release/outputs/deck.pptx
@@ -89,7 +89,16 @@
 Setup is short. Choose your Datadog site, then sign in with OAuth in the browser. Keys are an alternative, and any older manual server or custom connector should be removed first.
 Access is not widened. You still need the Datadog permissions for the data you query, and the plugin states that no Datadog credentials are sent to the model provider.
 Tool groups can be switched on or off, so a team can expose only the products it needs. Start with one narrow toolset.
-Treat the preview label as a rollout risk. The server is HIPAA eligible, yet you own compliance for the tools you connect, and government sites are not supported. Pilot with one team, keep permissions tight, then expand.</a:t>
+Treat the preview label as a rollout risk. The server is HIPAA eligible, yet you own compliance for the tools you connect, and government sites are not supported. Pilot with one team, keep permissions tight, then expand.
+Evidence: The Datadog MCP Server bridges Datadog observability data to AI agents, so logs, metrics, traces, dashboards and monitors can be queried in natural language. [ev-01] Datadog MCP Server
+Evidence: For Claude, including Claude Cowork, the official Datadog connector is the recommended path and includes MCP Apps for in-product visualizations. [ev-05] Set Up the Datadog MCP Server
+Evidence: Claude Code installs the Datadog plugin from the official Anthropic Plugin Marketplace; the plugin bundles the MCP Server with skills and auto-updates. [ev-06] Set Up the Datadog MCP Server
+Evidence: Setup asks you to choose a Datadog site and sign in with OAuth in the browser; API and application keys are a supported alternative. [ev-07] Set Up the Datadog MCP Server
+Evidence: Remove any separately registered Datadog MCP server or custom connector first to avoid conflicts. [ev-14] Datadog Claude Code Plugin
+Evidence: You need Datadog permissions for the resources you query, and the plugin states that no Datadog credentials are sent to the AI model provider. [ev-10] Set Up the Datadog MCP Server
+Evidence: Groups of MCP tools can be enabled or disabled with the toolsets command. [ev-11] Datadog Claude Code Plugin
+Evidence: The Datadog plugin and its marketplace listing are in Preview. [ev-03] Datadog Claude Code Plugin
+Evidence: The Datadog MCP Server is HIPAA-eligible, customers remain responsible for the compliance of the AI tools they connect, and the server is not supported on the Datadog government sites. [ev-12] Datadog MCP Server</a:t>
             </a:r>
           </a:p>
           <a:p>
@@ -321,7 +330,8 @@
                   <a:srgbClr val="111111"/>
                 </a:solidFill>
               </a:rPr>
-              <a:t>Explain that the plugin is a bridge to Datadog data for MCP agents.</a:t>
+              <a:t>Explain that the plugin is a bridge to Datadog data for MCP agents.
+Evidence: The Datadog MCP Server bridges Datadog observability data to AI agents, so logs, metrics, traces, dashboards and monitors can be queried in natural language. [ev-01] Datadog MCP Server</a:t>
             </a:r>
           </a:p>
           <a:p>
@@ -423,7 +433,9 @@
                   <a:srgbClr val="111111"/>
                 </a:solidFill>
               </a:rPr>
-              <a:t>Show the path from Datadog data to the team through the connector or plugin.</a:t>
+              <a:t>Show the path from Datadog data to the team through the connector or plugin.
+Evidence: For Claude, including Claude Cowork, the official Datadog connector is the recommended path and includes MCP Apps for in-product visualizations. [ev-05] Set Up the Datadog MCP Server
+Evidence: Claude Code installs the Datadog plugin from the official Anthropic Plugin Marketplace; the plugin bundles the MCP Server with skills and auto-updates. [ev-06] Set Up the Datadog MCP Server</a:t>
             </a:r>
           </a:p>
           <a:p>
@@ -525,7 +537,9 @@
                   <a:srgbClr val="111111"/>
                 </a:solidFill>
               </a:rPr>
-              <a:t>Walk through the guided setup and the conflict warning.</a:t>
+              <a:t>Walk through the guided setup and the conflict warning.
+Evidence: Setup asks you to choose a Datadog site and sign in with OAuth in the browser; API and application keys are a supported alternative. [ev-07] Set Up the Datadog MCP Server
+Evidence: Remove any separately registered Datadog MCP server or custom connector first to avoid conflicts. [ev-14] Datadog Claude Code Plugin</a:t>
             </a:r>
           </a:p>
           <a:p>
@@ -647,7 +661,8 @@
                   <a:srgbClr val="111111"/>
                 </a:solidFill>
               </a:rPr>
-              <a:t>Stress that the plugin does not widen access.</a:t>
+              <a:t>Stress that the plugin does not widen access.
+Evidence: You need Datadog permissions for the resources you query, and the plugin states that no Datadog credentials are sent to the AI model provider. [ev-10] Set Up the Datadog MCP Server</a:t>
             </a:r>
           </a:p>
           <a:p>
@@ -749,7 +764,8 @@
                   <a:srgbClr val="111111"/>
                 </a:solidFill>
               </a:rPr>
-              <a:t>Recommend starting with one narrow toolset.</a:t>
+              <a:t>Recommend starting with one narrow toolset.
+Evidence: Groups of MCP tools can be enabled or disabled with the toolsets command. [ev-11] Datadog Claude Code Plugin</a:t>
             </a:r>
           </a:p>
           <a:p>
@@ -841,7 +857,9 @@
                   <a:srgbClr val="111111"/>
                 </a:solidFill>
               </a:rPr>
-              <a:t>Close with the pilot recommendation and the preview caveat.</a:t>
+              <a:t>Close with the pilot recommendation and the preview caveat.
+Evidence: The Datadog plugin and its marketplace listing are in Preview. [ev-03] Datadog Claude Code Plugin
+Evidence: The Datadog MCP Server is HIPAA-eligible, customers remain responsible for the compliance of the AI tools they connect, and the server is not supported on the Datadog government sites. [ev-12] Datadog MCP Server</a:t>
             </a:r>
           </a:p>
           <a:p>
@@ -1317,7 +1335,7 @@
         <p:spPr>
           <a:xfrm>
             <a:off x="685800" y="3000000"/>
-            <a:ext cx="9600000" cy="1200000"/>
+            <a:ext cx="9600000" cy="1400000"/>
           </a:xfrm>
           <a:prstGeom prst="rect">
             <a:avLst/>
@@ -1449,7 +1467,7 @@
                   <a:srgbClr val="B3B4BF"/>
                 </a:solidFill>
               </a:rPr>
-              <a:t>datadog-cowork-plugin-r1</a:t>
+              <a:t>datadog-cowork-plugin-2026-04-am-michael-kokoro-onnx</a:t>
             </a:r>
           </a:p>
         </p:txBody>
@@ -1600,7 +1618,7 @@
         <p:spPr>
           <a:xfrm>
             <a:off x="685800" y="1750000"/>
-            <a:ext cx="5300000" cy="1400000"/>
+            <a:ext cx="3900000" cy="3900000"/>
           </a:xfrm>
           <a:prstGeom prst="rect">
             <a:avLst/>
@@ -1625,7 +1643,7 @@
               </a:spcAft>
             </a:pPr>
             <a:r>
-              <a:rPr lang="en-US" sz="1400">
+              <a:rPr lang="en-US" sz="2500">
                 <a:solidFill>
                   <a:srgbClr val="F4F5FF"/>
                 </a:solidFill>
@@ -1644,7 +1662,7 @@
         <p:spPr>
           <a:xfrm>
             <a:off x="548640" y="1800000"/>
-            <a:ext cx="45720" cy="1300000"/>
+            <a:ext cx="45720" cy="3800000"/>
           </a:xfrm>
           <a:prstGeom prst="rect">
             <a:avLst/>
@@ -1673,8 +1691,8 @@
         </p:blipFill>
         <p:spPr>
           <a:xfrm>
-            <a:off x="685800" y="3300000"/>
-            <a:ext cx="5066667" cy="2850000"/>
+            <a:off x="5000000" y="2021875"/>
+            <a:ext cx="6500000" cy="3656250"/>
           </a:xfrm>
           <a:prstGeom prst="rect">
             <a:avLst/>
@@ -1688,52 +1706,28 @@
       </p:pic>
       <p:sp>
         <p:nvSpPr>
-          <p:cNvPr id="7" name="Claim 1"/>
-          <p:cNvSpPr/>
-          <p:nvPr/>
-        </p:nvSpPr>
-        <p:spPr>
-          <a:xfrm>
-            <a:off x="6400000" y="1750000"/>
-            <a:ext cx="5105000" cy="1500000"/>
-          </a:xfrm>
-          <a:prstGeom prst="roundRect">
-            <a:avLst>
-              <a:gd name="adj" fmla="val 9000"/>
-            </a:avLst>
-          </a:prstGeom>
-          <a:solidFill>
-            <a:srgbClr val="1E202C"/>
-          </a:solidFill>
-          <a:ln w="12700">
-            <a:solidFill>
-              <a:srgbClr val="353743"/>
-            </a:solidFill>
-          </a:ln>
-        </p:spPr>
-        <p:txBody>
-          <a:bodyPr wrap="square" lIns="182880" tIns="91440" rIns="182880" bIns="91440" anchor="ctr">
+          <p:cNvPr id="7" name="Footer"/>
+          <p:cNvSpPr txBox="1"/>
+          <p:nvPr/>
+        </p:nvSpPr>
+        <p:spPr>
+          <a:xfrm>
+            <a:off x="685800" y="6250000"/>
+            <a:ext cx="9400000" cy="420000"/>
+          </a:xfrm>
+          <a:prstGeom prst="rect">
+            <a:avLst/>
+          </a:prstGeom>
+          <a:noFill/>
+          <a:ln>
+            <a:noFill/>
+          </a:ln>
+        </p:spPr>
+        <p:txBody>
+          <a:bodyPr wrap="square" lIns="182880" tIns="91440" rIns="182880" bIns="91440" anchor="t">
             <a:normAutofit/>
           </a:bodyPr>
           <a:lstStyle/>
-          <a:p>
-            <a:pPr algn="l">
-              <a:lnSpc>
-                <a:spcPct val="105000"/>
-              </a:lnSpc>
-              <a:spcAft>
-                <a:spcPts val="400"/>
-              </a:spcAft>
-            </a:pPr>
-            <a:r>
-              <a:rPr lang="en-US" sz="1200">
-                <a:solidFill>
-                  <a:srgbClr val="F4F5FF"/>
-                </a:solidFill>
-              </a:rPr>
-              <a:t>The Datadog MCP Server bridges Datadog observability data to AI agents, so logs, metrics, traces, dashboards and monitors can be queried in natural language.</a:t>
-            </a:r>
-          </a:p>
           <a:p>
             <a:pPr algn="l">
               <a:lnSpc>
@@ -1744,63 +1738,19 @@
               </a:spcAft>
             </a:pPr>
             <a:r>
-              <a:rPr lang="en-US" sz="1100">
+              <a:rPr lang="en-US" sz="1000">
                 <a:solidFill>
                   <a:srgbClr val="B3B4BF"/>
                 </a:solidFill>
               </a:rPr>
-              <a:t>[ev-01] Datadog MCP Server</a:t>
-            </a:r>
-          </a:p>
-        </p:txBody>
-      </p:sp>
-      <p:sp>
-        <p:nvSpPr>
-          <p:cNvPr id="8" name="Footer"/>
-          <p:cNvSpPr txBox="1"/>
-          <p:nvPr/>
-        </p:nvSpPr>
-        <p:spPr>
-          <a:xfrm>
-            <a:off x="685800" y="6250000"/>
-            <a:ext cx="9400000" cy="420000"/>
-          </a:xfrm>
-          <a:prstGeom prst="rect">
-            <a:avLst/>
-          </a:prstGeom>
-          <a:noFill/>
-          <a:ln>
-            <a:noFill/>
-          </a:ln>
-        </p:spPr>
-        <p:txBody>
-          <a:bodyPr wrap="square" lIns="182880" tIns="91440" rIns="182880" bIns="91440" anchor="t">
-            <a:normAutofit/>
-          </a:bodyPr>
-          <a:lstStyle/>
-          <a:p>
-            <a:pPr algn="l">
-              <a:lnSpc>
-                <a:spcPct val="105000"/>
-              </a:lnSpc>
-              <a:spcAft>
-                <a:spcPts val="0"/>
-              </a:spcAft>
-            </a:pPr>
-            <a:r>
-              <a:rPr lang="en-US" sz="1000">
-                <a:solidFill>
-                  <a:srgbClr val="B3B4BF"/>
-                </a:solidFill>
-              </a:rPr>
-              <a:t>Sources: [ev-01] Datadog MCP Server  ·  [ev-02] Datadog Claude Code Plugin</a:t>
-            </a:r>
-          </a:p>
-        </p:txBody>
-      </p:sp>
-      <p:sp>
-        <p:nvSpPr>
-          <p:cNvPr id="9" name="Slide number"/>
+              <a:t>Sources: Datadog MCP Server  ·  Datadog Claude Code Plugin</a:t>
+            </a:r>
+          </a:p>
+        </p:txBody>
+      </p:sp>
+      <p:sp>
+        <p:nvSpPr>
+          <p:cNvPr id="8" name="Slide number"/>
           <p:cNvSpPr txBox="1"/>
           <p:nvPr/>
         </p:nvSpPr>
@@ -1944,7 +1894,7 @@
         <p:spPr>
           <a:xfrm>
             <a:off x="685800" y="1750000"/>
-            <a:ext cx="5300000" cy="1400000"/>
+            <a:ext cx="3900000" cy="3900000"/>
           </a:xfrm>
           <a:prstGeom prst="rect">
             <a:avLst/>
@@ -1969,7 +1919,7 @@
               </a:spcAft>
             </a:pPr>
             <a:r>
-              <a:rPr lang="en-US" sz="1600">
+              <a:rPr lang="en-US" sz="2600">
                 <a:solidFill>
                   <a:srgbClr val="F4F5FF"/>
                 </a:solidFill>
@@ -1988,7 +1938,7 @@
         <p:spPr>
           <a:xfrm>
             <a:off x="548640" y="1800000"/>
-            <a:ext cx="45720" cy="1300000"/>
+            <a:ext cx="45720" cy="3800000"/>
           </a:xfrm>
           <a:prstGeom prst="rect">
             <a:avLst/>
@@ -2017,8 +1967,8 @@
         </p:blipFill>
         <p:spPr>
           <a:xfrm>
-            <a:off x="685800" y="3300000"/>
-            <a:ext cx="5066667" cy="2850000"/>
+            <a:off x="5000000" y="2021875"/>
+            <a:ext cx="6500000" cy="3656250"/>
           </a:xfrm>
           <a:prstGeom prst="rect">
             <a:avLst/>
@@ -2032,52 +1982,28 @@
       </p:pic>
       <p:sp>
         <p:nvSpPr>
-          <p:cNvPr id="7" name="Claim 1"/>
-          <p:cNvSpPr/>
-          <p:nvPr/>
-        </p:nvSpPr>
-        <p:spPr>
-          <a:xfrm>
-            <a:off x="6400000" y="1750000"/>
-            <a:ext cx="5105000" cy="1500000"/>
-          </a:xfrm>
-          <a:prstGeom prst="roundRect">
-            <a:avLst>
-              <a:gd name="adj" fmla="val 9000"/>
-            </a:avLst>
-          </a:prstGeom>
-          <a:solidFill>
-            <a:srgbClr val="1E202C"/>
-          </a:solidFill>
-          <a:ln w="12700">
-            <a:solidFill>
-              <a:srgbClr val="353743"/>
-            </a:solidFill>
-          </a:ln>
-        </p:spPr>
-        <p:txBody>
-          <a:bodyPr wrap="square" lIns="182880" tIns="91440" rIns="182880" bIns="91440" anchor="ctr">
+          <p:cNvPr id="7" name="Footer"/>
+          <p:cNvSpPr txBox="1"/>
+          <p:nvPr/>
+        </p:nvSpPr>
+        <p:spPr>
+          <a:xfrm>
+            <a:off x="685800" y="6250000"/>
+            <a:ext cx="9400000" cy="420000"/>
+          </a:xfrm>
+          <a:prstGeom prst="rect">
+            <a:avLst/>
+          </a:prstGeom>
+          <a:noFill/>
+          <a:ln>
+            <a:noFill/>
+          </a:ln>
+        </p:spPr>
+        <p:txBody>
+          <a:bodyPr wrap="square" lIns="182880" tIns="91440" rIns="182880" bIns="91440" anchor="t">
             <a:normAutofit/>
           </a:bodyPr>
           <a:lstStyle/>
-          <a:p>
-            <a:pPr algn="l">
-              <a:lnSpc>
-                <a:spcPct val="105000"/>
-              </a:lnSpc>
-              <a:spcAft>
-                <a:spcPts val="400"/>
-              </a:spcAft>
-            </a:pPr>
-            <a:r>
-              <a:rPr lang="en-US" sz="1400">
-                <a:solidFill>
-                  <a:srgbClr val="F4F5FF"/>
-                </a:solidFill>
-              </a:rPr>
-              <a:t>For Claude, including Claude Cowork, the official Datadog connector is the recommended path and includes MCP Apps for in-product visualizations.</a:t>
-            </a:r>
-          </a:p>
           <a:p>
             <a:pPr algn="l">
               <a:lnSpc>
@@ -2088,131 +2014,19 @@
               </a:spcAft>
             </a:pPr>
             <a:r>
-              <a:rPr lang="en-US" sz="1100">
+              <a:rPr lang="en-US" sz="1000">
                 <a:solidFill>
                   <a:srgbClr val="B3B4BF"/>
                 </a:solidFill>
               </a:rPr>
-              <a:t>[ev-05] Set Up the Datadog MCP Server</a:t>
-            </a:r>
-          </a:p>
-        </p:txBody>
-      </p:sp>
-      <p:sp>
-        <p:nvSpPr>
-          <p:cNvPr id="8" name="Claim 2"/>
-          <p:cNvSpPr/>
-          <p:nvPr/>
-        </p:nvSpPr>
-        <p:spPr>
-          <a:xfrm>
-            <a:off x="6400000" y="3400000"/>
-            <a:ext cx="5105000" cy="1500000"/>
-          </a:xfrm>
-          <a:prstGeom prst="roundRect">
-            <a:avLst>
-              <a:gd name="adj" fmla="val 9000"/>
-            </a:avLst>
-          </a:prstGeom>
-          <a:solidFill>
-            <a:srgbClr val="1E202C"/>
-          </a:solidFill>
-          <a:ln w="12700">
-            <a:solidFill>
-              <a:srgbClr val="353743"/>
-            </a:solidFill>
-          </a:ln>
-        </p:spPr>
-        <p:txBody>
-          <a:bodyPr wrap="square" lIns="182880" tIns="91440" rIns="182880" bIns="91440" anchor="ctr">
-            <a:normAutofit/>
-          </a:bodyPr>
-          <a:lstStyle/>
-          <a:p>
-            <a:pPr algn="l">
-              <a:lnSpc>
-                <a:spcPct val="105000"/>
-              </a:lnSpc>
-              <a:spcAft>
-                <a:spcPts val="400"/>
-              </a:spcAft>
-            </a:pPr>
-            <a:r>
-              <a:rPr lang="en-US" sz="1300">
-                <a:solidFill>
-                  <a:srgbClr val="F4F5FF"/>
-                </a:solidFill>
-              </a:rPr>
-              <a:t>Claude Code installs the Datadog plugin from the official Anthropic Plugin Marketplace; the plugin bundles the MCP Server with skills and auto-updates.</a:t>
-            </a:r>
-          </a:p>
-          <a:p>
-            <a:pPr algn="l">
-              <a:lnSpc>
-                <a:spcPct val="105000"/>
-              </a:lnSpc>
-              <a:spcAft>
-                <a:spcPts val="0"/>
-              </a:spcAft>
-            </a:pPr>
-            <a:r>
-              <a:rPr lang="en-US" sz="1100">
-                <a:solidFill>
-                  <a:srgbClr val="B3B4BF"/>
-                </a:solidFill>
-              </a:rPr>
-              <a:t>[ev-06] Set Up the Datadog MCP Server</a:t>
-            </a:r>
-          </a:p>
-        </p:txBody>
-      </p:sp>
-      <p:sp>
-        <p:nvSpPr>
-          <p:cNvPr id="9" name="Footer"/>
-          <p:cNvSpPr txBox="1"/>
-          <p:nvPr/>
-        </p:nvSpPr>
-        <p:spPr>
-          <a:xfrm>
-            <a:off x="685800" y="6250000"/>
-            <a:ext cx="9400000" cy="420000"/>
-          </a:xfrm>
-          <a:prstGeom prst="rect">
-            <a:avLst/>
-          </a:prstGeom>
-          <a:noFill/>
-          <a:ln>
-            <a:noFill/>
-          </a:ln>
-        </p:spPr>
-        <p:txBody>
-          <a:bodyPr wrap="square" lIns="182880" tIns="91440" rIns="182880" bIns="91440" anchor="t">
-            <a:normAutofit/>
-          </a:bodyPr>
-          <a:lstStyle/>
-          <a:p>
-            <a:pPr algn="l">
-              <a:lnSpc>
-                <a:spcPct val="105000"/>
-              </a:lnSpc>
-              <a:spcAft>
-                <a:spcPts val="0"/>
-              </a:spcAft>
-            </a:pPr>
-            <a:r>
-              <a:rPr lang="en-US" sz="1000">
-                <a:solidFill>
-                  <a:srgbClr val="B3B4BF"/>
-                </a:solidFill>
-              </a:rPr>
-              <a:t>Sources: [ev-05] Set Up the Datadog MCP Server  ·  [ev-06] Set Up the Datadog MCP Server</a:t>
-            </a:r>
-          </a:p>
-        </p:txBody>
-      </p:sp>
-      <p:sp>
-        <p:nvSpPr>
-          <p:cNvPr id="10" name="Slide number"/>
+              <a:t>Sources: Set Up the Datadog MCP Server</a:t>
+            </a:r>
+          </a:p>
+        </p:txBody>
+      </p:sp>
+      <p:sp>
+        <p:nvSpPr>
+          <p:cNvPr id="8" name="Slide number"/>
           <p:cNvSpPr txBox="1"/>
           <p:nvPr/>
         </p:nvSpPr>
@@ -2356,7 +2170,7 @@
         <p:spPr>
           <a:xfrm>
             <a:off x="685800" y="1750000"/>
-            <a:ext cx="5300000" cy="1400000"/>
+            <a:ext cx="3900000" cy="3900000"/>
           </a:xfrm>
           <a:prstGeom prst="rect">
             <a:avLst/>
@@ -2381,7 +2195,7 @@
               </a:spcAft>
             </a:pPr>
             <a:r>
-              <a:rPr lang="en-US" sz="1500">
+              <a:rPr lang="en-US" sz="2500">
                 <a:solidFill>
                   <a:srgbClr val="F4F5FF"/>
                 </a:solidFill>
@@ -2400,7 +2214,7 @@
         <p:spPr>
           <a:xfrm>
             <a:off x="548640" y="1800000"/>
-            <a:ext cx="45720" cy="1300000"/>
+            <a:ext cx="45720" cy="3800000"/>
           </a:xfrm>
           <a:prstGeom prst="rect">
             <a:avLst/>
@@ -2429,8 +2243,8 @@
         </p:blipFill>
         <p:spPr>
           <a:xfrm>
-            <a:off x="685800" y="3300000"/>
-            <a:ext cx="5066667" cy="2850000"/>
+            <a:off x="5000000" y="2021875"/>
+            <a:ext cx="6500000" cy="3656250"/>
           </a:xfrm>
           <a:prstGeom prst="rect">
             <a:avLst/>
@@ -2444,52 +2258,28 @@
       </p:pic>
       <p:sp>
         <p:nvSpPr>
-          <p:cNvPr id="7" name="Claim 1"/>
-          <p:cNvSpPr/>
-          <p:nvPr/>
-        </p:nvSpPr>
-        <p:spPr>
-          <a:xfrm>
-            <a:off x="6400000" y="1750000"/>
-            <a:ext cx="5105000" cy="1500000"/>
-          </a:xfrm>
-          <a:prstGeom prst="roundRect">
-            <a:avLst>
-              <a:gd name="adj" fmla="val 9000"/>
-            </a:avLst>
-          </a:prstGeom>
-          <a:solidFill>
-            <a:srgbClr val="1E202C"/>
-          </a:solidFill>
-          <a:ln w="12700">
-            <a:solidFill>
-              <a:srgbClr val="353743"/>
-            </a:solidFill>
-          </a:ln>
-        </p:spPr>
-        <p:txBody>
-          <a:bodyPr wrap="square" lIns="182880" tIns="91440" rIns="182880" bIns="91440" anchor="ctr">
+          <p:cNvPr id="7" name="Footer"/>
+          <p:cNvSpPr txBox="1"/>
+          <p:nvPr/>
+        </p:nvSpPr>
+        <p:spPr>
+          <a:xfrm>
+            <a:off x="685800" y="6250000"/>
+            <a:ext cx="9400000" cy="420000"/>
+          </a:xfrm>
+          <a:prstGeom prst="rect">
+            <a:avLst/>
+          </a:prstGeom>
+          <a:noFill/>
+          <a:ln>
+            <a:noFill/>
+          </a:ln>
+        </p:spPr>
+        <p:txBody>
+          <a:bodyPr wrap="square" lIns="182880" tIns="91440" rIns="182880" bIns="91440" anchor="t">
             <a:normAutofit/>
           </a:bodyPr>
           <a:lstStyle/>
-          <a:p>
-            <a:pPr algn="l">
-              <a:lnSpc>
-                <a:spcPct val="105000"/>
-              </a:lnSpc>
-              <a:spcAft>
-                <a:spcPts val="400"/>
-              </a:spcAft>
-            </a:pPr>
-            <a:r>
-              <a:rPr lang="en-US" sz="1500">
-                <a:solidFill>
-                  <a:srgbClr val="F4F5FF"/>
-                </a:solidFill>
-              </a:rPr>
-              <a:t>Setup asks you to choose a Datadog site and sign in with OAuth in the browser; API and application keys are a supported alternative.</a:t>
-            </a:r>
-          </a:p>
           <a:p>
             <a:pPr algn="l">
               <a:lnSpc>
@@ -2500,131 +2290,19 @@
               </a:spcAft>
             </a:pPr>
             <a:r>
-              <a:rPr lang="en-US" sz="1100">
+              <a:rPr lang="en-US" sz="1000">
                 <a:solidFill>
                   <a:srgbClr val="B3B4BF"/>
                 </a:solidFill>
               </a:rPr>
-              <a:t>[ev-07] Set Up the Datadog MCP Server</a:t>
-            </a:r>
-          </a:p>
-        </p:txBody>
-      </p:sp>
-      <p:sp>
-        <p:nvSpPr>
-          <p:cNvPr id="8" name="Claim 2"/>
-          <p:cNvSpPr/>
-          <p:nvPr/>
-        </p:nvSpPr>
-        <p:spPr>
-          <a:xfrm>
-            <a:off x="6400000" y="3400000"/>
-            <a:ext cx="5105000" cy="1500000"/>
-          </a:xfrm>
-          <a:prstGeom prst="roundRect">
-            <a:avLst>
-              <a:gd name="adj" fmla="val 9000"/>
-            </a:avLst>
-          </a:prstGeom>
-          <a:solidFill>
-            <a:srgbClr val="1E202C"/>
-          </a:solidFill>
-          <a:ln w="12700">
-            <a:solidFill>
-              <a:srgbClr val="353743"/>
-            </a:solidFill>
-          </a:ln>
-        </p:spPr>
-        <p:txBody>
-          <a:bodyPr wrap="square" lIns="182880" tIns="91440" rIns="182880" bIns="91440" anchor="ctr">
-            <a:normAutofit/>
-          </a:bodyPr>
-          <a:lstStyle/>
-          <a:p>
-            <a:pPr algn="l">
-              <a:lnSpc>
-                <a:spcPct val="105000"/>
-              </a:lnSpc>
-              <a:spcAft>
-                <a:spcPts val="400"/>
-              </a:spcAft>
-            </a:pPr>
-            <a:r>
-              <a:rPr lang="en-US" sz="1500">
-                <a:solidFill>
-                  <a:srgbClr val="F4F5FF"/>
-                </a:solidFill>
-              </a:rPr>
-              <a:t>Remove any separately registered Datadog MCP server or custom connector first to avoid conflicts.</a:t>
-            </a:r>
-          </a:p>
-          <a:p>
-            <a:pPr algn="l">
-              <a:lnSpc>
-                <a:spcPct val="105000"/>
-              </a:lnSpc>
-              <a:spcAft>
-                <a:spcPts val="0"/>
-              </a:spcAft>
-            </a:pPr>
-            <a:r>
-              <a:rPr lang="en-US" sz="1100">
-                <a:solidFill>
-                  <a:srgbClr val="B3B4BF"/>
-                </a:solidFill>
-              </a:rPr>
-              <a:t>[ev-14] Datadog Claude Code Plugin</a:t>
-            </a:r>
-          </a:p>
-        </p:txBody>
-      </p:sp>
-      <p:sp>
-        <p:nvSpPr>
-          <p:cNvPr id="9" name="Footer"/>
-          <p:cNvSpPr txBox="1"/>
-          <p:nvPr/>
-        </p:nvSpPr>
-        <p:spPr>
-          <a:xfrm>
-            <a:off x="685800" y="6250000"/>
-            <a:ext cx="9400000" cy="420000"/>
-          </a:xfrm>
-          <a:prstGeom prst="rect">
-            <a:avLst/>
-          </a:prstGeom>
-          <a:noFill/>
-          <a:ln>
-            <a:noFill/>
-          </a:ln>
-        </p:spPr>
-        <p:txBody>
-          <a:bodyPr wrap="square" lIns="182880" tIns="91440" rIns="182880" bIns="91440" anchor="t">
-            <a:normAutofit/>
-          </a:bodyPr>
-          <a:lstStyle/>
-          <a:p>
-            <a:pPr algn="l">
-              <a:lnSpc>
-                <a:spcPct val="105000"/>
-              </a:lnSpc>
-              <a:spcAft>
-                <a:spcPts val="0"/>
-              </a:spcAft>
-            </a:pPr>
-            <a:r>
-              <a:rPr lang="en-US" sz="1000">
-                <a:solidFill>
-                  <a:srgbClr val="B3B4BF"/>
-                </a:solidFill>
-              </a:rPr>
-              <a:t>Sources: [ev-07] Set Up the Datadog MCP Server  ·  [ev-08] Datadog Claude Code Plugin  ·  [ev-14] Datadog Claude Code Plugin</a:t>
-            </a:r>
-          </a:p>
-        </p:txBody>
-      </p:sp>
-      <p:sp>
-        <p:nvSpPr>
-          <p:cNvPr id="10" name="Slide number"/>
+              <a:t>Sources: Set Up the Datadog MCP Server  ·  Datadog Claude Code Plugin</a:t>
+            </a:r>
+          </a:p>
+        </p:txBody>
+      </p:sp>
+      <p:sp>
+        <p:nvSpPr>
+          <p:cNvPr id="8" name="Slide number"/>
           <p:cNvSpPr txBox="1"/>
           <p:nvPr/>
         </p:nvSpPr>
@@ -2768,7 +2446,7 @@
         <p:spPr>
           <a:xfrm>
             <a:off x="685800" y="1750000"/>
-            <a:ext cx="5300000" cy="1400000"/>
+            <a:ext cx="3900000" cy="3900000"/>
           </a:xfrm>
           <a:prstGeom prst="rect">
             <a:avLst/>
@@ -2793,7 +2471,7 @@
               </a:spcAft>
             </a:pPr>
             <a:r>
-              <a:rPr lang="en-US" sz="1800">
+              <a:rPr lang="en-US" sz="2600">
                 <a:solidFill>
                   <a:srgbClr val="F4F5FF"/>
                 </a:solidFill>
@@ -2812,7 +2490,7 @@
         <p:spPr>
           <a:xfrm>
             <a:off x="548640" y="1800000"/>
-            <a:ext cx="45720" cy="1300000"/>
+            <a:ext cx="45720" cy="3800000"/>
           </a:xfrm>
           <a:prstGeom prst="rect">
             <a:avLst/>
@@ -2841,8 +2519,8 @@
         </p:blipFill>
         <p:spPr>
           <a:xfrm>
-            <a:off x="685800" y="3300000"/>
-            <a:ext cx="5066667" cy="2850000"/>
+            <a:off x="5000000" y="2021875"/>
+            <a:ext cx="6500000" cy="3656250"/>
           </a:xfrm>
           <a:prstGeom prst="rect">
             <a:avLst/>
@@ -2856,52 +2534,28 @@
       </p:pic>
       <p:sp>
         <p:nvSpPr>
-          <p:cNvPr id="7" name="Claim 1"/>
-          <p:cNvSpPr/>
-          <p:nvPr/>
-        </p:nvSpPr>
-        <p:spPr>
-          <a:xfrm>
-            <a:off x="6400000" y="1750000"/>
-            <a:ext cx="5105000" cy="1500000"/>
-          </a:xfrm>
-          <a:prstGeom prst="roundRect">
-            <a:avLst>
-              <a:gd name="adj" fmla="val 9000"/>
-            </a:avLst>
-          </a:prstGeom>
-          <a:solidFill>
-            <a:srgbClr val="1E202C"/>
-          </a:solidFill>
-          <a:ln w="12700">
-            <a:solidFill>
-              <a:srgbClr val="353743"/>
-            </a:solidFill>
-          </a:ln>
-        </p:spPr>
-        <p:txBody>
-          <a:bodyPr wrap="square" lIns="182880" tIns="91440" rIns="182880" bIns="91440" anchor="ctr">
+          <p:cNvPr id="7" name="Footer"/>
+          <p:cNvSpPr txBox="1"/>
+          <p:nvPr/>
+        </p:nvSpPr>
+        <p:spPr>
+          <a:xfrm>
+            <a:off x="685800" y="6250000"/>
+            <a:ext cx="9400000" cy="420000"/>
+          </a:xfrm>
+          <a:prstGeom prst="rect">
+            <a:avLst/>
+          </a:prstGeom>
+          <a:noFill/>
+          <a:ln>
+            <a:noFill/>
+          </a:ln>
+        </p:spPr>
+        <p:txBody>
+          <a:bodyPr wrap="square" lIns="182880" tIns="91440" rIns="182880" bIns="91440" anchor="t">
             <a:normAutofit/>
           </a:bodyPr>
           <a:lstStyle/>
-          <a:p>
-            <a:pPr algn="l">
-              <a:lnSpc>
-                <a:spcPct val="105000"/>
-              </a:lnSpc>
-              <a:spcAft>
-                <a:spcPts val="400"/>
-              </a:spcAft>
-            </a:pPr>
-            <a:r>
-              <a:rPr lang="en-US" sz="1400">
-                <a:solidFill>
-                  <a:srgbClr val="F4F5FF"/>
-                </a:solidFill>
-              </a:rPr>
-              <a:t>You need Datadog permissions for the resources you query, and the plugin states that no Datadog credentials are sent to the AI model provider.</a:t>
-            </a:r>
-          </a:p>
           <a:p>
             <a:pPr algn="l">
               <a:lnSpc>
@@ -2912,63 +2566,19 @@
               </a:spcAft>
             </a:pPr>
             <a:r>
-              <a:rPr lang="en-US" sz="1100">
+              <a:rPr lang="en-US" sz="1000">
                 <a:solidFill>
                   <a:srgbClr val="B3B4BF"/>
                 </a:solidFill>
               </a:rPr>
-              <a:t>[ev-10] Set Up the Datadog MCP Server</a:t>
-            </a:r>
-          </a:p>
-        </p:txBody>
-      </p:sp>
-      <p:sp>
-        <p:nvSpPr>
-          <p:cNvPr id="8" name="Footer"/>
-          <p:cNvSpPr txBox="1"/>
-          <p:nvPr/>
-        </p:nvSpPr>
-        <p:spPr>
-          <a:xfrm>
-            <a:off x="685800" y="6250000"/>
-            <a:ext cx="9400000" cy="420000"/>
-          </a:xfrm>
-          <a:prstGeom prst="rect">
-            <a:avLst/>
-          </a:prstGeom>
-          <a:noFill/>
-          <a:ln>
-            <a:noFill/>
-          </a:ln>
-        </p:spPr>
-        <p:txBody>
-          <a:bodyPr wrap="square" lIns="182880" tIns="91440" rIns="182880" bIns="91440" anchor="t">
-            <a:normAutofit/>
-          </a:bodyPr>
-          <a:lstStyle/>
-          <a:p>
-            <a:pPr algn="l">
-              <a:lnSpc>
-                <a:spcPct val="105000"/>
-              </a:lnSpc>
-              <a:spcAft>
-                <a:spcPts val="0"/>
-              </a:spcAft>
-            </a:pPr>
-            <a:r>
-              <a:rPr lang="en-US" sz="1000">
-                <a:solidFill>
-                  <a:srgbClr val="B3B4BF"/>
-                </a:solidFill>
-              </a:rPr>
-              <a:t>Sources: [ev-10] Set Up the Datadog MCP Server  ·  [ev-09] Datadog Claude Code Plugin</a:t>
-            </a:r>
-          </a:p>
-        </p:txBody>
-      </p:sp>
-      <p:sp>
-        <p:nvSpPr>
-          <p:cNvPr id="9" name="Slide number"/>
+              <a:t>Sources: Set Up the Datadog MCP Server  ·  Datadog Claude Code Plugin</a:t>
+            </a:r>
+          </a:p>
+        </p:txBody>
+      </p:sp>
+      <p:sp>
+        <p:nvSpPr>
+          <p:cNvPr id="8" name="Slide number"/>
           <p:cNvSpPr txBox="1"/>
           <p:nvPr/>
         </p:nvSpPr>
@@ -3232,7 +2842,7 @@
                   <a:srgbClr val="B3B4BF"/>
                 </a:solidFill>
               </a:rPr>
-              <a:t>[ev-11] Datadog Claude Code Plugin</a:t>
+              <a:t>Datadog Claude Code Plugin</a:t>
             </a:r>
           </a:p>
         </p:txBody>
@@ -3276,7 +2886,7 @@
                   <a:srgbClr val="B3B4BF"/>
                 </a:solidFill>
               </a:rPr>
-              <a:t>Sources: [ev-11] Datadog Claude Code Plugin</a:t>
+              <a:t>Sources: Datadog Claude Code Plugin</a:t>
             </a:r>
           </a:p>
         </p:txBody>
@@ -3427,7 +3037,7 @@
         <p:spPr>
           <a:xfrm>
             <a:off x="685800" y="1750000"/>
-            <a:ext cx="5300000" cy="1400000"/>
+            <a:ext cx="3900000" cy="3900000"/>
           </a:xfrm>
           <a:prstGeom prst="rect">
             <a:avLst/>
@@ -3452,7 +3062,7 @@
               </a:spcAft>
             </a:pPr>
             <a:r>
-              <a:rPr lang="en-US" sz="1500">
+              <a:rPr lang="en-US" sz="2500">
                 <a:solidFill>
                   <a:srgbClr val="F4F5FF"/>
                 </a:solidFill>
@@ -3471,7 +3081,7 @@
         <p:spPr>
           <a:xfrm>
             <a:off x="548640" y="1800000"/>
-            <a:ext cx="45720" cy="1300000"/>
+            <a:ext cx="45720" cy="3800000"/>
           </a:xfrm>
           <a:prstGeom prst="rect">
             <a:avLst/>
@@ -3500,8 +3110,8 @@
         </p:blipFill>
         <p:spPr>
           <a:xfrm>
-            <a:off x="685800" y="3300000"/>
-            <a:ext cx="5066667" cy="2850000"/>
+            <a:off x="5000000" y="2021875"/>
+            <a:ext cx="6500000" cy="3656250"/>
           </a:xfrm>
           <a:prstGeom prst="rect">
             <a:avLst/>
@@ -3515,52 +3125,28 @@
       </p:pic>
       <p:sp>
         <p:nvSpPr>
-          <p:cNvPr id="7" name="Claim 1"/>
-          <p:cNvSpPr/>
-          <p:nvPr/>
-        </p:nvSpPr>
-        <p:spPr>
-          <a:xfrm>
-            <a:off x="6400000" y="1750000"/>
-            <a:ext cx="5105000" cy="1500000"/>
-          </a:xfrm>
-          <a:prstGeom prst="roundRect">
-            <a:avLst>
-              <a:gd name="adj" fmla="val 9000"/>
-            </a:avLst>
-          </a:prstGeom>
-          <a:solidFill>
-            <a:srgbClr val="1E202C"/>
-          </a:solidFill>
-          <a:ln w="12700">
-            <a:solidFill>
-              <a:srgbClr val="353743"/>
-            </a:solidFill>
-          </a:ln>
-        </p:spPr>
-        <p:txBody>
-          <a:bodyPr wrap="square" lIns="182880" tIns="91440" rIns="182880" bIns="91440" anchor="ctr">
+          <p:cNvPr id="7" name="Footer"/>
+          <p:cNvSpPr txBox="1"/>
+          <p:nvPr/>
+        </p:nvSpPr>
+        <p:spPr>
+          <a:xfrm>
+            <a:off x="685800" y="6250000"/>
+            <a:ext cx="9400000" cy="420000"/>
+          </a:xfrm>
+          <a:prstGeom prst="rect">
+            <a:avLst/>
+          </a:prstGeom>
+          <a:noFill/>
+          <a:ln>
+            <a:noFill/>
+          </a:ln>
+        </p:spPr>
+        <p:txBody>
+          <a:bodyPr wrap="square" lIns="182880" tIns="91440" rIns="182880" bIns="91440" anchor="t">
             <a:normAutofit/>
           </a:bodyPr>
           <a:lstStyle/>
-          <a:p>
-            <a:pPr algn="l">
-              <a:lnSpc>
-                <a:spcPct val="105000"/>
-              </a:lnSpc>
-              <a:spcAft>
-                <a:spcPts val="400"/>
-              </a:spcAft>
-            </a:pPr>
-            <a:r>
-              <a:rPr lang="en-US" sz="1600">
-                <a:solidFill>
-                  <a:srgbClr val="F4F5FF"/>
-                </a:solidFill>
-              </a:rPr>
-              <a:t>The Datadog plugin and its marketplace listing are in Preview.</a:t>
-            </a:r>
-          </a:p>
           <a:p>
             <a:pPr algn="l">
               <a:lnSpc>
@@ -3571,131 +3157,19 @@
               </a:spcAft>
             </a:pPr>
             <a:r>
-              <a:rPr lang="en-US" sz="1100">
+              <a:rPr lang="en-US" sz="1000">
                 <a:solidFill>
                   <a:srgbClr val="B3B4BF"/>
                 </a:solidFill>
               </a:rPr>
-              <a:t>[ev-03] Datadog Claude Code Plugin</a:t>
-            </a:r>
-          </a:p>
-        </p:txBody>
-      </p:sp>
-      <p:sp>
-        <p:nvSpPr>
-          <p:cNvPr id="8" name="Claim 2"/>
-          <p:cNvSpPr/>
-          <p:nvPr/>
-        </p:nvSpPr>
-        <p:spPr>
-          <a:xfrm>
-            <a:off x="6400000" y="3400000"/>
-            <a:ext cx="5105000" cy="1500000"/>
-          </a:xfrm>
-          <a:prstGeom prst="roundRect">
-            <a:avLst>
-              <a:gd name="adj" fmla="val 9000"/>
-            </a:avLst>
-          </a:prstGeom>
-          <a:solidFill>
-            <a:srgbClr val="1E202C"/>
-          </a:solidFill>
-          <a:ln w="12700">
-            <a:solidFill>
-              <a:srgbClr val="353743"/>
-            </a:solidFill>
-          </a:ln>
-        </p:spPr>
-        <p:txBody>
-          <a:bodyPr wrap="square" lIns="182880" tIns="91440" rIns="182880" bIns="91440" anchor="ctr">
-            <a:normAutofit/>
-          </a:bodyPr>
-          <a:lstStyle/>
-          <a:p>
-            <a:pPr algn="l">
-              <a:lnSpc>
-                <a:spcPct val="105000"/>
-              </a:lnSpc>
-              <a:spcAft>
-                <a:spcPts val="400"/>
-              </a:spcAft>
-            </a:pPr>
-            <a:r>
-              <a:rPr lang="en-US" sz="1200">
-                <a:solidFill>
-                  <a:srgbClr val="F4F5FF"/>
-                </a:solidFill>
-              </a:rPr>
-              <a:t>The Datadog MCP Server is HIPAA-eligible, customers remain responsible for the compliance of the AI tools they connect, and the server is not supported on the Datadog government sites.</a:t>
-            </a:r>
-          </a:p>
-          <a:p>
-            <a:pPr algn="l">
-              <a:lnSpc>
-                <a:spcPct val="105000"/>
-              </a:lnSpc>
-              <a:spcAft>
-                <a:spcPts val="0"/>
-              </a:spcAft>
-            </a:pPr>
-            <a:r>
-              <a:rPr lang="en-US" sz="1100">
-                <a:solidFill>
-                  <a:srgbClr val="B3B4BF"/>
-                </a:solidFill>
-              </a:rPr>
-              <a:t>[ev-12] Datadog MCP Server</a:t>
-            </a:r>
-          </a:p>
-        </p:txBody>
-      </p:sp>
-      <p:sp>
-        <p:nvSpPr>
-          <p:cNvPr id="9" name="Footer"/>
-          <p:cNvSpPr txBox="1"/>
-          <p:nvPr/>
-        </p:nvSpPr>
-        <p:spPr>
-          <a:xfrm>
-            <a:off x="685800" y="6250000"/>
-            <a:ext cx="9400000" cy="420000"/>
-          </a:xfrm>
-          <a:prstGeom prst="rect">
-            <a:avLst/>
-          </a:prstGeom>
-          <a:noFill/>
-          <a:ln>
-            <a:noFill/>
-          </a:ln>
-        </p:spPr>
-        <p:txBody>
-          <a:bodyPr wrap="square" lIns="182880" tIns="91440" rIns="182880" bIns="91440" anchor="t">
-            <a:normAutofit/>
-          </a:bodyPr>
-          <a:lstStyle/>
-          <a:p>
-            <a:pPr algn="l">
-              <a:lnSpc>
-                <a:spcPct val="105000"/>
-              </a:lnSpc>
-              <a:spcAft>
-                <a:spcPts val="0"/>
-              </a:spcAft>
-            </a:pPr>
-            <a:r>
-              <a:rPr lang="en-US" sz="1000">
-                <a:solidFill>
-                  <a:srgbClr val="B3B4BF"/>
-                </a:solidFill>
-              </a:rPr>
-              <a:t>Sources: [ev-03] Datadog Claude Code Plugin  ·  [ev-04] Datadog | Claude by Anthropic  ·  [ev-12] Datadog MCP Server</a:t>
-            </a:r>
-          </a:p>
-        </p:txBody>
-      </p:sp>
-      <p:sp>
-        <p:nvSpPr>
-          <p:cNvPr id="10" name="Slide number"/>
+              <a:t>Sources: Datadog Claude Code Plugin  ·  Datadog | Claude by Anthropic  ·  Datadog MCP Server  ·  +1 more</a:t>
+            </a:r>
+          </a:p>
+        </p:txBody>
+      </p:sp>
+      <p:sp>
+        <p:nvSpPr>
+          <p:cNvPr id="8" name="Slide number"/>
           <p:cNvSpPr txBox="1"/>
           <p:nvPr/>
         </p:nvSpPr>
@@ -3864,7 +3338,7 @@
               </a:spcAft>
             </a:pPr>
             <a:r>
-              <a:rPr lang="en-US" sz="1800" b="1">
+              <a:rPr lang="en-US" sz="1400" b="1">
                 <a:solidFill>
                   <a:srgbClr val="F4F5FF"/>
                 </a:solidFill>
@@ -3872,7 +3346,7 @@
               <a:t>Datadog MCP Server</a:t>
             </a:r>
             <a:r>
-              <a:rPr lang="en-US" sz="1200">
+              <a:rPr lang="en-US" sz="1100">
                 <a:solidFill>
                   <a:srgbClr val="B3B4BF"/>
                 </a:solidFill>
@@ -3886,11 +3360,11 @@
                 <a:spcPct val="105000"/>
               </a:lnSpc>
               <a:spcAft>
-                <a:spcPts val="1400"/>
+                <a:spcPts val="900"/>
               </a:spcAft>
             </a:pPr>
             <a:r>
-              <a:rPr lang="en-US" sz="1400">
+              <a:rPr lang="en-US" sz="1100">
                 <a:solidFill>
                   <a:srgbClr val="9D6CFF"/>
                 </a:solidFill>
@@ -3908,7 +3382,7 @@
               </a:spcAft>
             </a:pPr>
             <a:r>
-              <a:rPr lang="en-US" sz="1800" b="1">
+              <a:rPr lang="en-US" sz="1400" b="1">
                 <a:solidFill>
                   <a:srgbClr val="F4F5FF"/>
                 </a:solidFill>
@@ -3916,7 +3390,7 @@
               <a:t>Datadog Claude Code Plugin</a:t>
             </a:r>
             <a:r>
-              <a:rPr lang="en-US" sz="1200">
+              <a:rPr lang="en-US" sz="1100">
                 <a:solidFill>
                   <a:srgbClr val="B3B4BF"/>
                 </a:solidFill>
@@ -3930,11 +3404,11 @@
                 <a:spcPct val="105000"/>
               </a:lnSpc>
               <a:spcAft>
-                <a:spcPts val="1400"/>
+                <a:spcPts val="900"/>
               </a:spcAft>
             </a:pPr>
             <a:r>
-              <a:rPr lang="en-US" sz="1400">
+              <a:rPr lang="en-US" sz="1100">
                 <a:solidFill>
                   <a:srgbClr val="9D6CFF"/>
                 </a:solidFill>
@@ -3952,7 +3426,7 @@
               </a:spcAft>
             </a:pPr>
             <a:r>
-              <a:rPr lang="en-US" sz="1800" b="1">
+              <a:rPr lang="en-US" sz="1400" b="1">
                 <a:solidFill>
                   <a:srgbClr val="F4F5FF"/>
                 </a:solidFill>
@@ -3960,7 +3434,7 @@
               <a:t>Datadog | Claude by Anthropic</a:t>
             </a:r>
             <a:r>
-              <a:rPr lang="en-US" sz="1200">
+              <a:rPr lang="en-US" sz="1100">
                 <a:solidFill>
                   <a:srgbClr val="B3B4BF"/>
                 </a:solidFill>
@@ -3974,11 +3448,11 @@
                 <a:spcPct val="105000"/>
               </a:lnSpc>
               <a:spcAft>
-                <a:spcPts val="1400"/>
+                <a:spcPts val="900"/>
               </a:spcAft>
             </a:pPr>
             <a:r>
-              <a:rPr lang="en-US" sz="1400">
+              <a:rPr lang="en-US" sz="1100">
                 <a:solidFill>
                   <a:srgbClr val="9D6CFF"/>
                 </a:solidFill>
@@ -3996,7 +3470,7 @@
               </a:spcAft>
             </a:pPr>
             <a:r>
-              <a:rPr lang="en-US" sz="1800" b="1">
+              <a:rPr lang="en-US" sz="1400" b="1">
                 <a:solidFill>
                   <a:srgbClr val="F4F5FF"/>
                 </a:solidFill>
@@ -4004,7 +3478,7 @@
               <a:t>Set Up the Datadog MCP Server</a:t>
             </a:r>
             <a:r>
-              <a:rPr lang="en-US" sz="1200">
+              <a:rPr lang="en-US" sz="1100">
                 <a:solidFill>
                   <a:srgbClr val="B3B4BF"/>
                 </a:solidFill>
@@ -4018,11 +3492,11 @@
                 <a:spcPct val="105000"/>
               </a:lnSpc>
               <a:spcAft>
-                <a:spcPts val="1400"/>
+                <a:spcPts val="900"/>
               </a:spcAft>
             </a:pPr>
             <a:r>
-              <a:rPr lang="en-US" sz="1400">
+              <a:rPr lang="en-US" sz="1100">
                 <a:solidFill>
                   <a:srgbClr val="9D6CFF"/>
                 </a:solidFill>
@@ -4071,7 +3545,7 @@
                   <a:srgbClr val="B3B4BF"/>
                 </a:solidFill>
               </a:rPr>
-              <a:t>datadog-cowork-plugin-r1</a:t>
+              <a:t>datadog-cowork-plugin-2026-04-am-michael-kokoro-onnx</a:t>
             </a:r>
           </a:p>
         </p:txBody>

</xml_diff>

<commit_message>
feat: regenerate datadog-cowork-plugin with LF-stable release generation
- render four voices so release-verify passes on any checkout

🎙️ - Generated by Copilot

Co-authored-by: Copilot <223556219+Copilot@users.noreply.github.com>
</commit_message>
<xml_diff>
--- a/projects/datadog-cowork-plugin/release/outputs/deck.pptx
+++ b/projects/datadog-cowork-plugin/release/outputs/deck.pptx
@@ -1467,7 +1467,7 @@
                   <a:srgbClr val="B3B4BF"/>
                 </a:solidFill>
               </a:rPr>
-              <a:t>datadog-cowork-plugin-2026-04-am-michael-kokoro-onnx</a:t>
+              <a:t>datadog-cowork-plugin-2026-05-am-michael-kokoro-onnx</a:t>
             </a:r>
           </a:p>
         </p:txBody>
@@ -3545,7 +3545,7 @@
                   <a:srgbClr val="B3B4BF"/>
                 </a:solidFill>
               </a:rPr>
-              <a:t>datadog-cowork-plugin-2026-04-am-michael-kokoro-onnx</a:t>
+              <a:t>datadog-cowork-plugin-2026-05-am-michael-kokoro-onnx</a:t>
             </a:r>
           </a:p>
         </p:txBody>

</xml_diff>

<commit_message>
feat: regenerate datadog-cowork-plugin with its brand theme
- render four voices with the brand header band, palette and fonts

🎨 - Generated by Copilot

Co-authored-by: Copilot <223556219+Copilot@users.noreply.github.com>
</commit_message>
<xml_diff>
--- a/projects/datadog-cowork-plugin/release/outputs/deck.pptx
+++ b/projects/datadog-cowork-plugin/release/outputs/deck.pptx
@@ -20,6 +20,16 @@
     <a:defPPr>
       <a:defRPr lang="en-US"/>
     </a:defPPr>
+    <a:lvl1pPr algn="l" defTabSz="914400" marL="0" indent="0">
+      <a:defRPr sz="1800" kern="1200">
+        <a:solidFill>
+          <a:schemeClr val="tx1"/>
+        </a:solidFill>
+        <a:latin typeface="+mn-lt"/>
+        <a:ea typeface="+mn-ea"/>
+        <a:cs typeface="+mn-cs"/>
+      </a:defRPr>
+    </a:lvl1pPr>
   </p:defaultTextStyle>
 </p:presentation>
 </file>
@@ -83,13 +93,13 @@
                   <a:srgbClr val="111111"/>
                 </a:solidFill>
               </a:rPr>
-              <a:t>Datadog for Claude Cowork. Your telemetry, one question away. Here is what the plugin does, how it connects, and where a team should be careful.
-The Datadog Model Context Protocol server bridges your observability data to agents. Logs, metrics, traces, dashboards, and monitors become things you can simply ask about.
-For Claude, including Cowork, the official connector is the recommended path, and it adds in-product visualizations. Claude Code installs the same server as a plugin from the official marketplace.
-Setup is short. Choose your Datadog site, then sign in with OAuth in the browser. Keys are an alternative, and any older manual server or custom connector should be removed first.
-Access is not widened. You still need the Datadog permissions for the data you query, and the plugin states that no Datadog credentials are sent to the model provider.
-Tool groups can be switched on or off, so a team can expose only the products it needs. Start with one narrow toolset.
-Treat the preview label as a rollout risk. The server is HIPAA eligible, yet you own compliance for the tools you connect, and government sites are not supported. Pilot with one team, keep permissions tight, then expand.
+              <a:t>The Datadog plugin and connector let Claude query Datadog logs, metrics, traces, dashboards and monitors through the Datadog MCP Server.
+The Datadog MCP Server links your observability data to any agent that speaks the Model Context Protocol, so you ask instead of clicking through screens.
+Claude, including Cowork, uses the official connector. Claude Code installs the plugin from the official Anthropic marketplace.
+Choose your Datadog site and sign in with OAuth. Keys are supported, and older manual servers or custom connectors should be removed first.
+You need Datadog permissions for the resources you query, and no Datadog credentials are sent to the model provider.
+Enable or disable groups of MCP tools so the agent sees only the Datadog products your team needs.
+The plugin is in Preview. The server is HIPAA-eligible, but you own compliance for connected tools, and the government sites are unsupported.
 Evidence: The Datadog MCP Server bridges Datadog observability data to AI agents, so logs, metrics, traces, dashboards and monitors can be queried in natural language. [ev-01] Datadog MCP Server
 Evidence: For Claude, including Claude Cowork, the official Datadog connector is the recommended path and includes MCP Apps for in-product visualizations. [ev-05] Set Up the Datadog MCP Server
 Evidence: Claude Code installs the Datadog plugin from the official Anthropic Plugin Marketplace; the plugin bundles the MCP Server with skills and auto-updates. [ev-06] Set Up the Datadog MCP Server
@@ -1240,7 +1250,7 @@
     <p:bg>
       <p:bgPr>
         <a:solidFill>
-          <a:srgbClr val="0B0D1A"/>
+          <a:srgbClr val="F8F6FB"/>
         </a:solidFill>
         <a:effectLst/>
       </p:bgPr>
@@ -1254,20 +1264,20 @@
       <p:grpSpPr/>
       <p:sp>
         <p:nvSpPr>
-          <p:cNvPr id="2" name="Accent band"/>
+          <p:cNvPr id="2" name="Brand band"/>
           <p:cNvSpPr/>
           <p:nvPr/>
         </p:nvSpPr>
         <p:spPr>
           <a:xfrm>
             <a:off x="0" y="0"/>
-            <a:ext cx="12192000" cy="91440"/>
+            <a:ext cx="12192000" cy="502920"/>
           </a:xfrm>
           <a:prstGeom prst="rect">
             <a:avLst/>
           </a:prstGeom>
           <a:solidFill>
-            <a:srgbClr val="9D6CFF"/>
+            <a:srgbClr val="000000"/>
           </a:solidFill>
           <a:ln>
             <a:noFill/>
@@ -1276,14 +1286,36 @@
       </p:sp>
       <p:sp>
         <p:nvSpPr>
-          <p:cNvPr id="3" name="Title"/>
-          <p:cNvSpPr txBox="1"/>
-          <p:nvPr/>
-        </p:nvSpPr>
-        <p:spPr>
-          <a:xfrm>
-            <a:off x="685800" y="900000"/>
-            <a:ext cx="10820400" cy="2000000"/>
+          <p:cNvPr id="3" name="Highlight rule"/>
+          <p:cNvSpPr/>
+          <p:nvPr/>
+        </p:nvSpPr>
+        <p:spPr>
+          <a:xfrm>
+            <a:off x="0" y="502920"/>
+            <a:ext cx="12192000" cy="45720"/>
+          </a:xfrm>
+          <a:prstGeom prst="rect">
+            <a:avLst/>
+          </a:prstGeom>
+          <a:solidFill>
+            <a:srgbClr val="BEAAFF"/>
+          </a:solidFill>
+          <a:ln>
+            <a:noFill/>
+          </a:ln>
+        </p:spPr>
+      </p:sp>
+      <p:sp>
+        <p:nvSpPr>
+          <p:cNvPr id="4" name="Deck kicker"/>
+          <p:cNvSpPr txBox="1"/>
+          <p:nvPr/>
+        </p:nvSpPr>
+        <p:spPr>
+          <a:xfrm>
+            <a:off x="685800" y="0"/>
+            <a:ext cx="8400000" cy="502920"/>
           </a:xfrm>
           <a:prstGeom prst="rect">
             <a:avLst/>
@@ -1308,45 +1340,74 @@
               </a:spcAft>
             </a:pPr>
             <a:r>
-              <a:rPr lang="en-US" sz="3600" b="1">
-                <a:solidFill>
-                  <a:srgbClr val="F4F5FF"/>
-                </a:solidFill>
-              </a:rPr>
-              <a:t>Datadog for Claude Cowork.</a:t>
-            </a:r>
-            <a:r>
-              <a:rPr lang="en-US" sz="3600" b="1">
-                <a:solidFill>
-                  <a:srgbClr val="9D6CFF"/>
-                </a:solidFill>
-              </a:rPr>
-              <a:t> Observability by conversation.</a:t>
-            </a:r>
-          </a:p>
-        </p:txBody>
-      </p:sp>
-      <p:sp>
-        <p:nvSpPr>
-          <p:cNvPr id="4" name="Summary"/>
-          <p:cNvSpPr txBox="1"/>
-          <p:nvPr/>
-        </p:nvSpPr>
-        <p:spPr>
-          <a:xfrm>
-            <a:off x="685800" y="3000000"/>
-            <a:ext cx="9600000" cy="1400000"/>
-          </a:xfrm>
-          <a:prstGeom prst="rect">
-            <a:avLst/>
-          </a:prstGeom>
-          <a:noFill/>
-          <a:ln>
-            <a:noFill/>
-          </a:ln>
-        </p:spPr>
-        <p:txBody>
-          <a:bodyPr wrap="square" lIns="182880" tIns="91440" rIns="182880" bIns="91440" anchor="t">
+              <a:rPr lang="en-US" sz="1100" b="1" cap="all" spc="120">
+                <a:solidFill>
+                  <a:srgbClr val="FFFFFF"/>
+                </a:solidFill>
+              </a:rPr>
+              <a:t>Datadog for Claude Cowork</a:t>
+            </a:r>
+          </a:p>
+        </p:txBody>
+      </p:sp>
+      <p:sp>
+        <p:nvSpPr>
+          <p:cNvPr id="5" name="Slide number"/>
+          <p:cNvSpPr txBox="1"/>
+          <p:nvPr/>
+        </p:nvSpPr>
+        <p:spPr>
+          <a:xfrm>
+            <a:off x="9100000" y="0"/>
+            <a:ext cx="2406400" cy="502920"/>
+          </a:xfrm>
+          <a:prstGeom prst="rect">
+            <a:avLst/>
+          </a:prstGeom>
+          <a:noFill/>
+          <a:ln>
+            <a:noFill/>
+          </a:ln>
+        </p:spPr>
+        <p:txBody>
+          <a:bodyPr wrap="square" lIns="182880" tIns="91440" rIns="182880" bIns="91440" anchor="ctr">
+            <a:normAutofit/>
+          </a:bodyPr>
+          <a:lstStyle/>
+          <a:p>
+            <a:pPr algn="r"/>
+            <a:r>
+              <a:rPr lang="en-US" sz="1100" b="1" cap="all" spc="120">
+                <a:solidFill>
+                  <a:srgbClr val="B8B8B8"/>
+                </a:solidFill>
+              </a:rPr>
+              <a:t>1 / 8</a:t>
+            </a:r>
+          </a:p>
+        </p:txBody>
+      </p:sp>
+      <p:sp>
+        <p:nvSpPr>
+          <p:cNvPr id="6" name="Title"/>
+          <p:cNvSpPr txBox="1"/>
+          <p:nvPr/>
+        </p:nvSpPr>
+        <p:spPr>
+          <a:xfrm>
+            <a:off x="685800" y="1100000"/>
+            <a:ext cx="10820400" cy="2000000"/>
+          </a:xfrm>
+          <a:prstGeom prst="rect">
+            <a:avLst/>
+          </a:prstGeom>
+          <a:noFill/>
+          <a:ln>
+            <a:noFill/>
+          </a:ln>
+        </p:spPr>
+        <p:txBody>
+          <a:bodyPr wrap="square" lIns="182880" tIns="91440" rIns="182880" bIns="91440" anchor="ctr">
             <a:normAutofit/>
           </a:bodyPr>
           <a:lstStyle/>
@@ -1360,43 +1421,47 @@
               </a:spcAft>
             </a:pPr>
             <a:r>
-              <a:rPr lang="en-US" sz="1900">
-                <a:solidFill>
-                  <a:srgbClr val="B3B4BF"/>
-                </a:solidFill>
-              </a:rPr>
-              <a:t>The Datadog plugin and connector let Claude query Datadog logs, metrics, traces, dashboards and monitors through the Datadog MCP Server.</a:t>
-            </a:r>
-          </a:p>
-        </p:txBody>
-      </p:sp>
-      <p:sp>
-        <p:nvSpPr>
-          <p:cNvPr id="5" name="Decision"/>
-          <p:cNvSpPr/>
-          <p:nvPr/>
-        </p:nvSpPr>
-        <p:spPr>
-          <a:xfrm>
-            <a:off x="685800" y="4500000"/>
-            <a:ext cx="10820400" cy="1000000"/>
-          </a:xfrm>
-          <a:prstGeom prst="roundRect">
-            <a:avLst>
-              <a:gd name="adj" fmla="val 9000"/>
-            </a:avLst>
-          </a:prstGeom>
-          <a:solidFill>
-            <a:srgbClr val="221C3F"/>
-          </a:solidFill>
-          <a:ln w="12700">
-            <a:solidFill>
-              <a:srgbClr val="9D6CFF"/>
-            </a:solidFill>
-          </a:ln>
-        </p:spPr>
-        <p:txBody>
-          <a:bodyPr wrap="square" lIns="182880" tIns="91440" rIns="182880" bIns="91440" anchor="ctr">
+              <a:rPr lang="en-US" sz="3600" b="1">
+                <a:solidFill>
+                  <a:srgbClr val="000000"/>
+                </a:solidFill>
+                <a:latin typeface="+mj-lt"/>
+              </a:rPr>
+              <a:t>Datadog for Claude Cowork.</a:t>
+            </a:r>
+            <a:r>
+              <a:rPr lang="en-US" sz="3600" b="1">
+                <a:solidFill>
+                  <a:srgbClr val="632CA6"/>
+                </a:solidFill>
+                <a:latin typeface="+mj-lt"/>
+              </a:rPr>
+              <a:t> Observability by conversation.</a:t>
+            </a:r>
+          </a:p>
+        </p:txBody>
+      </p:sp>
+      <p:sp>
+        <p:nvSpPr>
+          <p:cNvPr id="7" name="Summary"/>
+          <p:cNvSpPr txBox="1"/>
+          <p:nvPr/>
+        </p:nvSpPr>
+        <p:spPr>
+          <a:xfrm>
+            <a:off x="685800" y="3150000"/>
+            <a:ext cx="9600000" cy="1400000"/>
+          </a:xfrm>
+          <a:prstGeom prst="rect">
+            <a:avLst/>
+          </a:prstGeom>
+          <a:noFill/>
+          <a:ln>
+            <a:noFill/>
+          </a:ln>
+        </p:spPr>
+        <p:txBody>
+          <a:bodyPr wrap="square" lIns="182880" tIns="91440" rIns="182880" bIns="91440" anchor="t">
             <a:normAutofit/>
           </a:bodyPr>
           <a:lstStyle/>
@@ -1410,45 +1475,43 @@
               </a:spcAft>
             </a:pPr>
             <a:r>
-              <a:rPr lang="en-US" sz="1400" b="1">
-                <a:solidFill>
-                  <a:srgbClr val="9D6CFF"/>
-                </a:solidFill>
-              </a:rPr>
-              <a:t>DECISION  </a:t>
-            </a:r>
-            <a:r>
-              <a:rPr lang="en-US" sz="1600" b="1">
-                <a:solidFill>
-                  <a:srgbClr val="F4F5FF"/>
-                </a:solidFill>
-              </a:rPr>
-              <a:t>Pilot the Datadog connector with one team, keep Datadog permissions scoped, and treat the Preview status as a rollout risk.</a:t>
-            </a:r>
-          </a:p>
-        </p:txBody>
-      </p:sp>
-      <p:sp>
-        <p:nvSpPr>
-          <p:cNvPr id="6" name="Footer"/>
-          <p:cNvSpPr txBox="1"/>
-          <p:nvPr/>
-        </p:nvSpPr>
-        <p:spPr>
-          <a:xfrm>
-            <a:off x="685800" y="6250000"/>
-            <a:ext cx="9400000" cy="420000"/>
-          </a:xfrm>
-          <a:prstGeom prst="rect">
-            <a:avLst/>
-          </a:prstGeom>
-          <a:noFill/>
-          <a:ln>
-            <a:noFill/>
-          </a:ln>
-        </p:spPr>
-        <p:txBody>
-          <a:bodyPr wrap="square" lIns="182880" tIns="91440" rIns="182880" bIns="91440" anchor="t">
+              <a:rPr lang="en-US" sz="1900">
+                <a:solidFill>
+                  <a:srgbClr val="666666"/>
+                </a:solidFill>
+              </a:rPr>
+              <a:t>The Datadog plugin and connector let Claude query Datadog logs, metrics, traces, dashboards and monitors through the Datadog MCP Server.</a:t>
+            </a:r>
+          </a:p>
+        </p:txBody>
+      </p:sp>
+      <p:sp>
+        <p:nvSpPr>
+          <p:cNvPr id="8" name="Decision"/>
+          <p:cNvSpPr/>
+          <p:nvPr/>
+        </p:nvSpPr>
+        <p:spPr>
+          <a:xfrm>
+            <a:off x="685800" y="4650000"/>
+            <a:ext cx="10820400" cy="1000000"/>
+          </a:xfrm>
+          <a:prstGeom prst="roundRect">
+            <a:avLst>
+              <a:gd name="adj" fmla="val 6000"/>
+            </a:avLst>
+          </a:prstGeom>
+          <a:solidFill>
+            <a:srgbClr val="F5F2FF"/>
+          </a:solidFill>
+          <a:ln w="12700">
+            <a:solidFill>
+              <a:srgbClr val="76699E"/>
+            </a:solidFill>
+          </a:ln>
+        </p:spPr>
+        <p:txBody>
+          <a:bodyPr wrap="square" lIns="182880" tIns="91440" rIns="182880" bIns="91440" anchor="ctr">
             <a:normAutofit/>
           </a:bodyPr>
           <a:lstStyle/>
@@ -1462,26 +1525,34 @@
               </a:spcAft>
             </a:pPr>
             <a:r>
-              <a:rPr lang="en-US" sz="1000">
-                <a:solidFill>
-                  <a:srgbClr val="B3B4BF"/>
-                </a:solidFill>
-              </a:rPr>
-              <a:t>datadog-cowork-plugin-2026-05-am-michael-kokoro-onnx</a:t>
-            </a:r>
-          </a:p>
-        </p:txBody>
-      </p:sp>
-      <p:sp>
-        <p:nvSpPr>
-          <p:cNvPr id="7" name="Slide number"/>
-          <p:cNvSpPr txBox="1"/>
-          <p:nvPr/>
-        </p:nvSpPr>
-        <p:spPr>
-          <a:xfrm>
-            <a:off x="10100000" y="6250000"/>
-            <a:ext cx="1400000" cy="420000"/>
+              <a:rPr lang="en-US" sz="1400" b="1">
+                <a:solidFill>
+                  <a:srgbClr val="632CA6"/>
+                </a:solidFill>
+              </a:rPr>
+              <a:t>DECISION  </a:t>
+            </a:r>
+            <a:r>
+              <a:rPr lang="en-US" sz="1600" b="1">
+                <a:solidFill>
+                  <a:srgbClr val="000000"/>
+                </a:solidFill>
+              </a:rPr>
+              <a:t>Pilot the Datadog connector with one team, keep Datadog permissions scoped, and treat the Preview status as a rollout risk.</a:t>
+            </a:r>
+          </a:p>
+        </p:txBody>
+      </p:sp>
+      <p:sp>
+        <p:nvSpPr>
+          <p:cNvPr id="9" name="Footer"/>
+          <p:cNvSpPr txBox="1"/>
+          <p:nvPr/>
+        </p:nvSpPr>
+        <p:spPr>
+          <a:xfrm>
+            <a:off x="685800" y="6250000"/>
+            <a:ext cx="10820400" cy="420000"/>
           </a:xfrm>
           <a:prstGeom prst="rect">
             <a:avLst/>
@@ -1497,14 +1568,21 @@
           </a:bodyPr>
           <a:lstStyle/>
           <a:p>
-            <a:pPr algn="r"/>
+            <a:pPr algn="l">
+              <a:lnSpc>
+                <a:spcPct val="105000"/>
+              </a:lnSpc>
+              <a:spcAft>
+                <a:spcPts val="0"/>
+              </a:spcAft>
+            </a:pPr>
             <a:r>
               <a:rPr lang="en-US" sz="1000">
                 <a:solidFill>
-                  <a:srgbClr val="B3B4BF"/>
-                </a:solidFill>
-              </a:rPr>
-              <a:t>1 / 8</a:t>
+                  <a:srgbClr val="666666"/>
+                </a:solidFill>
+              </a:rPr>
+              <a:t>datadog-cowork-plugin-2026-06-am-michael-kokoro-onnx</a:t>
             </a:r>
           </a:p>
         </p:txBody>
@@ -1523,7 +1601,7 @@
     <p:bg>
       <p:bgPr>
         <a:solidFill>
-          <a:srgbClr val="0B0D1A"/>
+          <a:srgbClr val="F8F6FB"/>
         </a:solidFill>
         <a:effectLst/>
       </p:bgPr>
@@ -1537,20 +1615,20 @@
       <p:grpSpPr/>
       <p:sp>
         <p:nvSpPr>
-          <p:cNvPr id="2" name="Accent band"/>
+          <p:cNvPr id="2" name="Brand band"/>
           <p:cNvSpPr/>
           <p:nvPr/>
         </p:nvSpPr>
         <p:spPr>
           <a:xfrm>
             <a:off x="0" y="0"/>
-            <a:ext cx="12192000" cy="91440"/>
+            <a:ext cx="12192000" cy="502920"/>
           </a:xfrm>
           <a:prstGeom prst="rect">
             <a:avLst/>
           </a:prstGeom>
           <a:solidFill>
-            <a:srgbClr val="9D6CFF"/>
+            <a:srgbClr val="000000"/>
           </a:solidFill>
           <a:ln>
             <a:noFill/>
@@ -1559,14 +1637,36 @@
       </p:sp>
       <p:sp>
         <p:nvSpPr>
-          <p:cNvPr id="3" name="Title"/>
-          <p:cNvSpPr txBox="1"/>
-          <p:nvPr/>
-        </p:nvSpPr>
-        <p:spPr>
-          <a:xfrm>
-            <a:off x="685800" y="420000"/>
-            <a:ext cx="10820400" cy="1150000"/>
+          <p:cNvPr id="3" name="Highlight rule"/>
+          <p:cNvSpPr/>
+          <p:nvPr/>
+        </p:nvSpPr>
+        <p:spPr>
+          <a:xfrm>
+            <a:off x="0" y="502920"/>
+            <a:ext cx="12192000" cy="45720"/>
+          </a:xfrm>
+          <a:prstGeom prst="rect">
+            <a:avLst/>
+          </a:prstGeom>
+          <a:solidFill>
+            <a:srgbClr val="BEAAFF"/>
+          </a:solidFill>
+          <a:ln>
+            <a:noFill/>
+          </a:ln>
+        </p:spPr>
+      </p:sp>
+      <p:sp>
+        <p:nvSpPr>
+          <p:cNvPr id="4" name="Deck kicker"/>
+          <p:cNvSpPr txBox="1"/>
+          <p:nvPr/>
+        </p:nvSpPr>
+        <p:spPr>
+          <a:xfrm>
+            <a:off x="685800" y="0"/>
+            <a:ext cx="8400000" cy="502920"/>
           </a:xfrm>
           <a:prstGeom prst="rect">
             <a:avLst/>
@@ -1591,45 +1691,74 @@
               </a:spcAft>
             </a:pPr>
             <a:r>
-              <a:rPr lang="en-US" sz="2900" b="1">
-                <a:solidFill>
-                  <a:srgbClr val="F4F5FF"/>
-                </a:solidFill>
-              </a:rPr>
-              <a:t>A bridge.</a:t>
-            </a:r>
-            <a:r>
-              <a:rPr lang="en-US" sz="2900" b="1">
-                <a:solidFill>
-                  <a:srgbClr val="9D6CFF"/>
-                </a:solidFill>
-              </a:rPr>
-              <a:t> Not a dashboard.</a:t>
-            </a:r>
-          </a:p>
-        </p:txBody>
-      </p:sp>
-      <p:sp>
-        <p:nvSpPr>
-          <p:cNvPr id="4" name="Body"/>
-          <p:cNvSpPr txBox="1"/>
-          <p:nvPr/>
-        </p:nvSpPr>
-        <p:spPr>
-          <a:xfrm>
-            <a:off x="685800" y="1750000"/>
-            <a:ext cx="3900000" cy="3900000"/>
-          </a:xfrm>
-          <a:prstGeom prst="rect">
-            <a:avLst/>
-          </a:prstGeom>
-          <a:noFill/>
-          <a:ln>
-            <a:noFill/>
-          </a:ln>
-        </p:spPr>
-        <p:txBody>
-          <a:bodyPr wrap="square" lIns="182880" tIns="91440" rIns="182880" bIns="91440" anchor="t">
+              <a:rPr lang="en-US" sz="1100" b="1" cap="all" spc="120">
+                <a:solidFill>
+                  <a:srgbClr val="FFFFFF"/>
+                </a:solidFill>
+              </a:rPr>
+              <a:t>Datadog for Claude Cowork</a:t>
+            </a:r>
+          </a:p>
+        </p:txBody>
+      </p:sp>
+      <p:sp>
+        <p:nvSpPr>
+          <p:cNvPr id="5" name="Slide number"/>
+          <p:cNvSpPr txBox="1"/>
+          <p:nvPr/>
+        </p:nvSpPr>
+        <p:spPr>
+          <a:xfrm>
+            <a:off x="9100000" y="0"/>
+            <a:ext cx="2406400" cy="502920"/>
+          </a:xfrm>
+          <a:prstGeom prst="rect">
+            <a:avLst/>
+          </a:prstGeom>
+          <a:noFill/>
+          <a:ln>
+            <a:noFill/>
+          </a:ln>
+        </p:spPr>
+        <p:txBody>
+          <a:bodyPr wrap="square" lIns="182880" tIns="91440" rIns="182880" bIns="91440" anchor="ctr">
+            <a:normAutofit/>
+          </a:bodyPr>
+          <a:lstStyle/>
+          <a:p>
+            <a:pPr algn="r"/>
+            <a:r>
+              <a:rPr lang="en-US" sz="1100" b="1" cap="all" spc="120">
+                <a:solidFill>
+                  <a:srgbClr val="B8B8B8"/>
+                </a:solidFill>
+              </a:rPr>
+              <a:t>2 / 8</a:t>
+            </a:r>
+          </a:p>
+        </p:txBody>
+      </p:sp>
+      <p:sp>
+        <p:nvSpPr>
+          <p:cNvPr id="6" name="Title"/>
+          <p:cNvSpPr txBox="1"/>
+          <p:nvPr/>
+        </p:nvSpPr>
+        <p:spPr>
+          <a:xfrm>
+            <a:off x="685800" y="700000"/>
+            <a:ext cx="10820400" cy="1150000"/>
+          </a:xfrm>
+          <a:prstGeom prst="rect">
+            <a:avLst/>
+          </a:prstGeom>
+          <a:noFill/>
+          <a:ln>
+            <a:noFill/>
+          </a:ln>
+        </p:spPr>
+        <p:txBody>
+          <a:bodyPr wrap="square" lIns="182880" tIns="91440" rIns="182880" bIns="91440" anchor="ctr">
             <a:normAutofit/>
           </a:bodyPr>
           <a:lstStyle/>
@@ -1643,77 +1772,36 @@
               </a:spcAft>
             </a:pPr>
             <a:r>
-              <a:rPr lang="en-US" sz="2500">
-                <a:solidFill>
-                  <a:srgbClr val="F4F5FF"/>
-                </a:solidFill>
-              </a:rPr>
-              <a:t>The Datadog MCP Server links your observability data to any agent that speaks the Model Context Protocol, so you ask instead of clicking through screens.</a:t>
-            </a:r>
-          </a:p>
-        </p:txBody>
-      </p:sp>
-      <p:sp>
-        <p:nvSpPr>
-          <p:cNvPr id="5" name="Accent rule"/>
-          <p:cNvSpPr/>
-          <p:nvPr/>
-        </p:nvSpPr>
-        <p:spPr>
-          <a:xfrm>
-            <a:off x="548640" y="1800000"/>
-            <a:ext cx="45720" cy="3800000"/>
-          </a:xfrm>
-          <a:prstGeom prst="rect">
-            <a:avLst/>
-          </a:prstGeom>
-          <a:solidFill>
-            <a:srgbClr val="9D6CFF"/>
-          </a:solidFill>
-          <a:ln>
-            <a:noFill/>
-          </a:ln>
-        </p:spPr>
-      </p:sp>
-      <p:pic>
-        <p:nvPicPr>
-          <p:cNvPr id="6" name="Asset visual-what-it-is" descr="Datadog data reaches an MCP-capable agent through the Datadog MCP Server. (mermaid diagram)"/>
-          <p:cNvPicPr>
-            <a:picLocks noChangeAspect="1"/>
-          </p:cNvPicPr>
-          <p:nvPr/>
-        </p:nvPicPr>
-        <p:blipFill>
-          <a:blip r:embed="rIdImage1"/>
-          <a:stretch>
-            <a:fillRect/>
-          </a:stretch>
-        </p:blipFill>
-        <p:spPr>
-          <a:xfrm>
-            <a:off x="5000000" y="2021875"/>
-            <a:ext cx="6500000" cy="3656250"/>
-          </a:xfrm>
-          <a:prstGeom prst="rect">
-            <a:avLst/>
-          </a:prstGeom>
-          <a:ln>
-            <a:solidFill>
-              <a:srgbClr val="D9D9D9"/>
-            </a:solidFill>
-          </a:ln>
-        </p:spPr>
-      </p:pic>
-      <p:sp>
-        <p:nvSpPr>
-          <p:cNvPr id="7" name="Footer"/>
-          <p:cNvSpPr txBox="1"/>
-          <p:nvPr/>
-        </p:nvSpPr>
-        <p:spPr>
-          <a:xfrm>
-            <a:off x="685800" y="6250000"/>
-            <a:ext cx="9400000" cy="420000"/>
+              <a:rPr lang="en-US" sz="2900" b="1">
+                <a:solidFill>
+                  <a:srgbClr val="000000"/>
+                </a:solidFill>
+                <a:latin typeface="+mj-lt"/>
+              </a:rPr>
+              <a:t>A bridge.</a:t>
+            </a:r>
+            <a:r>
+              <a:rPr lang="en-US" sz="2900" b="1">
+                <a:solidFill>
+                  <a:srgbClr val="632CA6"/>
+                </a:solidFill>
+                <a:latin typeface="+mj-lt"/>
+              </a:rPr>
+              <a:t> Not a dashboard.</a:t>
+            </a:r>
+          </a:p>
+        </p:txBody>
+      </p:sp>
+      <p:sp>
+        <p:nvSpPr>
+          <p:cNvPr id="7" name="Body"/>
+          <p:cNvSpPr txBox="1"/>
+          <p:nvPr/>
+        </p:nvSpPr>
+        <p:spPr>
+          <a:xfrm>
+            <a:off x="685800" y="1950000"/>
+            <a:ext cx="3900000" cy="3900000"/>
           </a:xfrm>
           <a:prstGeom prst="rect">
             <a:avLst/>
@@ -1738,26 +1826,77 @@
               </a:spcAft>
             </a:pPr>
             <a:r>
-              <a:rPr lang="en-US" sz="1000">
-                <a:solidFill>
-                  <a:srgbClr val="B3B4BF"/>
-                </a:solidFill>
-              </a:rPr>
-              <a:t>Sources: Datadog MCP Server  ·  Datadog Claude Code Plugin</a:t>
-            </a:r>
-          </a:p>
-        </p:txBody>
-      </p:sp>
-      <p:sp>
-        <p:nvSpPr>
-          <p:cNvPr id="8" name="Slide number"/>
-          <p:cNvSpPr txBox="1"/>
-          <p:nvPr/>
-        </p:nvSpPr>
-        <p:spPr>
-          <a:xfrm>
-            <a:off x="10100000" y="6250000"/>
-            <a:ext cx="1400000" cy="420000"/>
+              <a:rPr lang="en-US" sz="2500">
+                <a:solidFill>
+                  <a:srgbClr val="000000"/>
+                </a:solidFill>
+              </a:rPr>
+              <a:t>The Datadog MCP Server links your observability data to any agent that speaks the Model Context Protocol, so you ask instead of clicking through screens.</a:t>
+            </a:r>
+          </a:p>
+        </p:txBody>
+      </p:sp>
+      <p:sp>
+        <p:nvSpPr>
+          <p:cNvPr id="8" name="Accent rule"/>
+          <p:cNvSpPr/>
+          <p:nvPr/>
+        </p:nvSpPr>
+        <p:spPr>
+          <a:xfrm>
+            <a:off x="548640" y="2000000"/>
+            <a:ext cx="45720" cy="3800000"/>
+          </a:xfrm>
+          <a:prstGeom prst="rect">
+            <a:avLst/>
+          </a:prstGeom>
+          <a:solidFill>
+            <a:srgbClr val="632CA6"/>
+          </a:solidFill>
+          <a:ln>
+            <a:noFill/>
+          </a:ln>
+        </p:spPr>
+      </p:sp>
+      <p:pic>
+        <p:nvPicPr>
+          <p:cNvPr id="9" name="Asset visual-what-it-is" descr="Datadog data reaches an MCP-capable agent through the Datadog MCP Server. (mermaid diagram)"/>
+          <p:cNvPicPr>
+            <a:picLocks noChangeAspect="1"/>
+          </p:cNvPicPr>
+          <p:nvPr/>
+        </p:nvPicPr>
+        <p:blipFill>
+          <a:blip r:embed="rIdImage1"/>
+          <a:stretch>
+            <a:fillRect/>
+          </a:stretch>
+        </p:blipFill>
+        <p:spPr>
+          <a:xfrm>
+            <a:off x="5000000" y="2221875"/>
+            <a:ext cx="6500000" cy="3656250"/>
+          </a:xfrm>
+          <a:prstGeom prst="rect">
+            <a:avLst/>
+          </a:prstGeom>
+          <a:ln>
+            <a:solidFill>
+              <a:srgbClr val="D9D9D9"/>
+            </a:solidFill>
+          </a:ln>
+        </p:spPr>
+      </p:pic>
+      <p:sp>
+        <p:nvSpPr>
+          <p:cNvPr id="10" name="Footer"/>
+          <p:cNvSpPr txBox="1"/>
+          <p:nvPr/>
+        </p:nvSpPr>
+        <p:spPr>
+          <a:xfrm>
+            <a:off x="685800" y="6250000"/>
+            <a:ext cx="10820400" cy="420000"/>
           </a:xfrm>
           <a:prstGeom prst="rect">
             <a:avLst/>
@@ -1773,14 +1912,21 @@
           </a:bodyPr>
           <a:lstStyle/>
           <a:p>
-            <a:pPr algn="r"/>
+            <a:pPr algn="l">
+              <a:lnSpc>
+                <a:spcPct val="105000"/>
+              </a:lnSpc>
+              <a:spcAft>
+                <a:spcPts val="0"/>
+              </a:spcAft>
+            </a:pPr>
             <a:r>
               <a:rPr lang="en-US" sz="1000">
                 <a:solidFill>
-                  <a:srgbClr val="B3B4BF"/>
-                </a:solidFill>
-              </a:rPr>
-              <a:t>2 / 8</a:t>
+                  <a:srgbClr val="666666"/>
+                </a:solidFill>
+              </a:rPr>
+              <a:t>Sources: Datadog MCP Server  ·  Datadog Claude Code Plugin</a:t>
             </a:r>
           </a:p>
         </p:txBody>
@@ -1799,7 +1945,7 @@
     <p:bg>
       <p:bgPr>
         <a:solidFill>
-          <a:srgbClr val="0B0D1A"/>
+          <a:srgbClr val="F8F6FB"/>
         </a:solidFill>
         <a:effectLst/>
       </p:bgPr>
@@ -1813,20 +1959,20 @@
       <p:grpSpPr/>
       <p:sp>
         <p:nvSpPr>
-          <p:cNvPr id="2" name="Accent band"/>
+          <p:cNvPr id="2" name="Brand band"/>
           <p:cNvSpPr/>
           <p:nvPr/>
         </p:nvSpPr>
         <p:spPr>
           <a:xfrm>
             <a:off x="0" y="0"/>
-            <a:ext cx="12192000" cy="91440"/>
+            <a:ext cx="12192000" cy="502920"/>
           </a:xfrm>
           <a:prstGeom prst="rect">
             <a:avLst/>
           </a:prstGeom>
           <a:solidFill>
-            <a:srgbClr val="9D6CFF"/>
+            <a:srgbClr val="000000"/>
           </a:solidFill>
           <a:ln>
             <a:noFill/>
@@ -1835,14 +1981,36 @@
       </p:sp>
       <p:sp>
         <p:nvSpPr>
-          <p:cNvPr id="3" name="Title"/>
-          <p:cNvSpPr txBox="1"/>
-          <p:nvPr/>
-        </p:nvSpPr>
-        <p:spPr>
-          <a:xfrm>
-            <a:off x="685800" y="420000"/>
-            <a:ext cx="10820400" cy="1150000"/>
+          <p:cNvPr id="3" name="Highlight rule"/>
+          <p:cNvSpPr/>
+          <p:nvPr/>
+        </p:nvSpPr>
+        <p:spPr>
+          <a:xfrm>
+            <a:off x="0" y="502920"/>
+            <a:ext cx="12192000" cy="45720"/>
+          </a:xfrm>
+          <a:prstGeom prst="rect">
+            <a:avLst/>
+          </a:prstGeom>
+          <a:solidFill>
+            <a:srgbClr val="BEAAFF"/>
+          </a:solidFill>
+          <a:ln>
+            <a:noFill/>
+          </a:ln>
+        </p:spPr>
+      </p:sp>
+      <p:sp>
+        <p:nvSpPr>
+          <p:cNvPr id="4" name="Deck kicker"/>
+          <p:cNvSpPr txBox="1"/>
+          <p:nvPr/>
+        </p:nvSpPr>
+        <p:spPr>
+          <a:xfrm>
+            <a:off x="685800" y="0"/>
+            <a:ext cx="8400000" cy="502920"/>
           </a:xfrm>
           <a:prstGeom prst="rect">
             <a:avLst/>
@@ -1867,45 +2035,74 @@
               </a:spcAft>
             </a:pPr>
             <a:r>
-              <a:rPr lang="en-US" sz="2900" b="1">
-                <a:solidFill>
-                  <a:srgbClr val="F4F5FF"/>
-                </a:solidFill>
-              </a:rPr>
-              <a:t>Where it runs.</a:t>
-            </a:r>
-            <a:r>
-              <a:rPr lang="en-US" sz="2900" b="1">
-                <a:solidFill>
-                  <a:srgbClr val="9D6CFF"/>
-                </a:solidFill>
-              </a:rPr>
-              <a:t> Cowork and Claude Code.</a:t>
-            </a:r>
-          </a:p>
-        </p:txBody>
-      </p:sp>
-      <p:sp>
-        <p:nvSpPr>
-          <p:cNvPr id="4" name="Body"/>
-          <p:cNvSpPr txBox="1"/>
-          <p:nvPr/>
-        </p:nvSpPr>
-        <p:spPr>
-          <a:xfrm>
-            <a:off x="685800" y="1750000"/>
-            <a:ext cx="3900000" cy="3900000"/>
-          </a:xfrm>
-          <a:prstGeom prst="rect">
-            <a:avLst/>
-          </a:prstGeom>
-          <a:noFill/>
-          <a:ln>
-            <a:noFill/>
-          </a:ln>
-        </p:spPr>
-        <p:txBody>
-          <a:bodyPr wrap="square" lIns="182880" tIns="91440" rIns="182880" bIns="91440" anchor="t">
+              <a:rPr lang="en-US" sz="1100" b="1" cap="all" spc="120">
+                <a:solidFill>
+                  <a:srgbClr val="FFFFFF"/>
+                </a:solidFill>
+              </a:rPr>
+              <a:t>Datadog for Claude Cowork</a:t>
+            </a:r>
+          </a:p>
+        </p:txBody>
+      </p:sp>
+      <p:sp>
+        <p:nvSpPr>
+          <p:cNvPr id="5" name="Slide number"/>
+          <p:cNvSpPr txBox="1"/>
+          <p:nvPr/>
+        </p:nvSpPr>
+        <p:spPr>
+          <a:xfrm>
+            <a:off x="9100000" y="0"/>
+            <a:ext cx="2406400" cy="502920"/>
+          </a:xfrm>
+          <a:prstGeom prst="rect">
+            <a:avLst/>
+          </a:prstGeom>
+          <a:noFill/>
+          <a:ln>
+            <a:noFill/>
+          </a:ln>
+        </p:spPr>
+        <p:txBody>
+          <a:bodyPr wrap="square" lIns="182880" tIns="91440" rIns="182880" bIns="91440" anchor="ctr">
+            <a:normAutofit/>
+          </a:bodyPr>
+          <a:lstStyle/>
+          <a:p>
+            <a:pPr algn="r"/>
+            <a:r>
+              <a:rPr lang="en-US" sz="1100" b="1" cap="all" spc="120">
+                <a:solidFill>
+                  <a:srgbClr val="B8B8B8"/>
+                </a:solidFill>
+              </a:rPr>
+              <a:t>3 / 8</a:t>
+            </a:r>
+          </a:p>
+        </p:txBody>
+      </p:sp>
+      <p:sp>
+        <p:nvSpPr>
+          <p:cNvPr id="6" name="Title"/>
+          <p:cNvSpPr txBox="1"/>
+          <p:nvPr/>
+        </p:nvSpPr>
+        <p:spPr>
+          <a:xfrm>
+            <a:off x="685800" y="700000"/>
+            <a:ext cx="10820400" cy="1150000"/>
+          </a:xfrm>
+          <a:prstGeom prst="rect">
+            <a:avLst/>
+          </a:prstGeom>
+          <a:noFill/>
+          <a:ln>
+            <a:noFill/>
+          </a:ln>
+        </p:spPr>
+        <p:txBody>
+          <a:bodyPr wrap="square" lIns="182880" tIns="91440" rIns="182880" bIns="91440" anchor="ctr">
             <a:normAutofit/>
           </a:bodyPr>
           <a:lstStyle/>
@@ -1919,77 +2116,36 @@
               </a:spcAft>
             </a:pPr>
             <a:r>
-              <a:rPr lang="en-US" sz="2600">
-                <a:solidFill>
-                  <a:srgbClr val="F4F5FF"/>
-                </a:solidFill>
-              </a:rPr>
-              <a:t>Claude, including Cowork, uses the official connector. Claude Code installs the plugin from the official Anthropic marketplace.</a:t>
-            </a:r>
-          </a:p>
-        </p:txBody>
-      </p:sp>
-      <p:sp>
-        <p:nvSpPr>
-          <p:cNvPr id="5" name="Accent rule"/>
-          <p:cNvSpPr/>
-          <p:nvPr/>
-        </p:nvSpPr>
-        <p:spPr>
-          <a:xfrm>
-            <a:off x="548640" y="1800000"/>
-            <a:ext cx="45720" cy="3800000"/>
-          </a:xfrm>
-          <a:prstGeom prst="rect">
-            <a:avLst/>
-          </a:prstGeom>
-          <a:solidFill>
-            <a:srgbClr val="9D6CFF"/>
-          </a:solidFill>
-          <a:ln>
-            <a:noFill/>
-          </a:ln>
-        </p:spPr>
-      </p:sp>
-      <p:pic>
-        <p:nvPicPr>
-          <p:cNvPr id="6" name="Asset mcp-flow" descr="Four-step flow: Datadog data, MCP server, Claude connector or plugin, your team, with existing permissions applying at each step."/>
-          <p:cNvPicPr>
-            <a:picLocks noChangeAspect="1"/>
-          </p:cNvPicPr>
-          <p:nvPr/>
-        </p:nvPicPr>
-        <p:blipFill>
-          <a:blip r:embed="rIdImage1"/>
-          <a:stretch>
-            <a:fillRect/>
-          </a:stretch>
-        </p:blipFill>
-        <p:spPr>
-          <a:xfrm>
-            <a:off x="5000000" y="2021875"/>
-            <a:ext cx="6500000" cy="3656250"/>
-          </a:xfrm>
-          <a:prstGeom prst="rect">
-            <a:avLst/>
-          </a:prstGeom>
-          <a:ln>
-            <a:solidFill>
-              <a:srgbClr val="D9D9D9"/>
-            </a:solidFill>
-          </a:ln>
-        </p:spPr>
-      </p:pic>
-      <p:sp>
-        <p:nvSpPr>
-          <p:cNvPr id="7" name="Footer"/>
-          <p:cNvSpPr txBox="1"/>
-          <p:nvPr/>
-        </p:nvSpPr>
-        <p:spPr>
-          <a:xfrm>
-            <a:off x="685800" y="6250000"/>
-            <a:ext cx="9400000" cy="420000"/>
+              <a:rPr lang="en-US" sz="2900" b="1">
+                <a:solidFill>
+                  <a:srgbClr val="000000"/>
+                </a:solidFill>
+                <a:latin typeface="+mj-lt"/>
+              </a:rPr>
+              <a:t>Where it runs.</a:t>
+            </a:r>
+            <a:r>
+              <a:rPr lang="en-US" sz="2900" b="1">
+                <a:solidFill>
+                  <a:srgbClr val="632CA6"/>
+                </a:solidFill>
+                <a:latin typeface="+mj-lt"/>
+              </a:rPr>
+              <a:t> Cowork and Claude Code.</a:t>
+            </a:r>
+          </a:p>
+        </p:txBody>
+      </p:sp>
+      <p:sp>
+        <p:nvSpPr>
+          <p:cNvPr id="7" name="Body"/>
+          <p:cNvSpPr txBox="1"/>
+          <p:nvPr/>
+        </p:nvSpPr>
+        <p:spPr>
+          <a:xfrm>
+            <a:off x="685800" y="1950000"/>
+            <a:ext cx="3900000" cy="3900000"/>
           </a:xfrm>
           <a:prstGeom prst="rect">
             <a:avLst/>
@@ -2014,26 +2170,77 @@
               </a:spcAft>
             </a:pPr>
             <a:r>
-              <a:rPr lang="en-US" sz="1000">
-                <a:solidFill>
-                  <a:srgbClr val="B3B4BF"/>
-                </a:solidFill>
-              </a:rPr>
-              <a:t>Sources: Set Up the Datadog MCP Server</a:t>
-            </a:r>
-          </a:p>
-        </p:txBody>
-      </p:sp>
-      <p:sp>
-        <p:nvSpPr>
-          <p:cNvPr id="8" name="Slide number"/>
-          <p:cNvSpPr txBox="1"/>
-          <p:nvPr/>
-        </p:nvSpPr>
-        <p:spPr>
-          <a:xfrm>
-            <a:off x="10100000" y="6250000"/>
-            <a:ext cx="1400000" cy="420000"/>
+              <a:rPr lang="en-US" sz="2600">
+                <a:solidFill>
+                  <a:srgbClr val="000000"/>
+                </a:solidFill>
+              </a:rPr>
+              <a:t>Claude, including Cowork, uses the official connector. Claude Code installs the plugin from the official Anthropic marketplace.</a:t>
+            </a:r>
+          </a:p>
+        </p:txBody>
+      </p:sp>
+      <p:sp>
+        <p:nvSpPr>
+          <p:cNvPr id="8" name="Accent rule"/>
+          <p:cNvSpPr/>
+          <p:nvPr/>
+        </p:nvSpPr>
+        <p:spPr>
+          <a:xfrm>
+            <a:off x="548640" y="2000000"/>
+            <a:ext cx="45720" cy="3800000"/>
+          </a:xfrm>
+          <a:prstGeom prst="rect">
+            <a:avLst/>
+          </a:prstGeom>
+          <a:solidFill>
+            <a:srgbClr val="632CA6"/>
+          </a:solidFill>
+          <a:ln>
+            <a:noFill/>
+          </a:ln>
+        </p:spPr>
+      </p:sp>
+      <p:pic>
+        <p:nvPicPr>
+          <p:cNvPr id="9" name="Asset mcp-flow" descr="Four-step flow: Datadog data, MCP server, Claude connector or plugin, your team, with existing permissions applying at each step."/>
+          <p:cNvPicPr>
+            <a:picLocks noChangeAspect="1"/>
+          </p:cNvPicPr>
+          <p:nvPr/>
+        </p:nvPicPr>
+        <p:blipFill>
+          <a:blip r:embed="rIdImage1"/>
+          <a:stretch>
+            <a:fillRect/>
+          </a:stretch>
+        </p:blipFill>
+        <p:spPr>
+          <a:xfrm>
+            <a:off x="5000000" y="2221875"/>
+            <a:ext cx="6500000" cy="3656250"/>
+          </a:xfrm>
+          <a:prstGeom prst="rect">
+            <a:avLst/>
+          </a:prstGeom>
+          <a:ln>
+            <a:solidFill>
+              <a:srgbClr val="D9D9D9"/>
+            </a:solidFill>
+          </a:ln>
+        </p:spPr>
+      </p:pic>
+      <p:sp>
+        <p:nvSpPr>
+          <p:cNvPr id="10" name="Footer"/>
+          <p:cNvSpPr txBox="1"/>
+          <p:nvPr/>
+        </p:nvSpPr>
+        <p:spPr>
+          <a:xfrm>
+            <a:off x="685800" y="6250000"/>
+            <a:ext cx="10820400" cy="420000"/>
           </a:xfrm>
           <a:prstGeom prst="rect">
             <a:avLst/>
@@ -2049,14 +2256,21 @@
           </a:bodyPr>
           <a:lstStyle/>
           <a:p>
-            <a:pPr algn="r"/>
+            <a:pPr algn="l">
+              <a:lnSpc>
+                <a:spcPct val="105000"/>
+              </a:lnSpc>
+              <a:spcAft>
+                <a:spcPts val="0"/>
+              </a:spcAft>
+            </a:pPr>
             <a:r>
               <a:rPr lang="en-US" sz="1000">
                 <a:solidFill>
-                  <a:srgbClr val="B3B4BF"/>
-                </a:solidFill>
-              </a:rPr>
-              <a:t>3 / 8</a:t>
+                  <a:srgbClr val="666666"/>
+                </a:solidFill>
+              </a:rPr>
+              <a:t>Sources: Set Up the Datadog MCP Server</a:t>
             </a:r>
           </a:p>
         </p:txBody>
@@ -2075,7 +2289,7 @@
     <p:bg>
       <p:bgPr>
         <a:solidFill>
-          <a:srgbClr val="0B0D1A"/>
+          <a:srgbClr val="F8F6FB"/>
         </a:solidFill>
         <a:effectLst/>
       </p:bgPr>
@@ -2089,20 +2303,20 @@
       <p:grpSpPr/>
       <p:sp>
         <p:nvSpPr>
-          <p:cNvPr id="2" name="Accent band"/>
+          <p:cNvPr id="2" name="Brand band"/>
           <p:cNvSpPr/>
           <p:nvPr/>
         </p:nvSpPr>
         <p:spPr>
           <a:xfrm>
             <a:off x="0" y="0"/>
-            <a:ext cx="12192000" cy="91440"/>
+            <a:ext cx="12192000" cy="502920"/>
           </a:xfrm>
           <a:prstGeom prst="rect">
             <a:avLst/>
           </a:prstGeom>
           <a:solidFill>
-            <a:srgbClr val="9D6CFF"/>
+            <a:srgbClr val="000000"/>
           </a:solidFill>
           <a:ln>
             <a:noFill/>
@@ -2111,14 +2325,36 @@
       </p:sp>
       <p:sp>
         <p:nvSpPr>
-          <p:cNvPr id="3" name="Title"/>
-          <p:cNvSpPr txBox="1"/>
-          <p:nvPr/>
-        </p:nvSpPr>
-        <p:spPr>
-          <a:xfrm>
-            <a:off x="685800" y="420000"/>
-            <a:ext cx="10820400" cy="1150000"/>
+          <p:cNvPr id="3" name="Highlight rule"/>
+          <p:cNvSpPr/>
+          <p:nvPr/>
+        </p:nvSpPr>
+        <p:spPr>
+          <a:xfrm>
+            <a:off x="0" y="502920"/>
+            <a:ext cx="12192000" cy="45720"/>
+          </a:xfrm>
+          <a:prstGeom prst="rect">
+            <a:avLst/>
+          </a:prstGeom>
+          <a:solidFill>
+            <a:srgbClr val="BEAAFF"/>
+          </a:solidFill>
+          <a:ln>
+            <a:noFill/>
+          </a:ln>
+        </p:spPr>
+      </p:sp>
+      <p:sp>
+        <p:nvSpPr>
+          <p:cNvPr id="4" name="Deck kicker"/>
+          <p:cNvSpPr txBox="1"/>
+          <p:nvPr/>
+        </p:nvSpPr>
+        <p:spPr>
+          <a:xfrm>
+            <a:off x="685800" y="0"/>
+            <a:ext cx="8400000" cy="502920"/>
           </a:xfrm>
           <a:prstGeom prst="rect">
             <a:avLst/>
@@ -2143,45 +2379,74 @@
               </a:spcAft>
             </a:pPr>
             <a:r>
-              <a:rPr lang="en-US" sz="2900" b="1">
-                <a:solidFill>
-                  <a:srgbClr val="F4F5FF"/>
-                </a:solidFill>
-              </a:rPr>
-              <a:t>Set up.</a:t>
-            </a:r>
-            <a:r>
-              <a:rPr lang="en-US" sz="2900" b="1">
-                <a:solidFill>
-                  <a:srgbClr val="9D6CFF"/>
-                </a:solidFill>
-              </a:rPr>
-              <a:t> Pick a site, sign in.</a:t>
-            </a:r>
-          </a:p>
-        </p:txBody>
-      </p:sp>
-      <p:sp>
-        <p:nvSpPr>
-          <p:cNvPr id="4" name="Body"/>
-          <p:cNvSpPr txBox="1"/>
-          <p:nvPr/>
-        </p:nvSpPr>
-        <p:spPr>
-          <a:xfrm>
-            <a:off x="685800" y="1750000"/>
-            <a:ext cx="3900000" cy="3900000"/>
-          </a:xfrm>
-          <a:prstGeom prst="rect">
-            <a:avLst/>
-          </a:prstGeom>
-          <a:noFill/>
-          <a:ln>
-            <a:noFill/>
-          </a:ln>
-        </p:spPr>
-        <p:txBody>
-          <a:bodyPr wrap="square" lIns="182880" tIns="91440" rIns="182880" bIns="91440" anchor="t">
+              <a:rPr lang="en-US" sz="1100" b="1" cap="all" spc="120">
+                <a:solidFill>
+                  <a:srgbClr val="FFFFFF"/>
+                </a:solidFill>
+              </a:rPr>
+              <a:t>Datadog for Claude Cowork</a:t>
+            </a:r>
+          </a:p>
+        </p:txBody>
+      </p:sp>
+      <p:sp>
+        <p:nvSpPr>
+          <p:cNvPr id="5" name="Slide number"/>
+          <p:cNvSpPr txBox="1"/>
+          <p:nvPr/>
+        </p:nvSpPr>
+        <p:spPr>
+          <a:xfrm>
+            <a:off x="9100000" y="0"/>
+            <a:ext cx="2406400" cy="502920"/>
+          </a:xfrm>
+          <a:prstGeom prst="rect">
+            <a:avLst/>
+          </a:prstGeom>
+          <a:noFill/>
+          <a:ln>
+            <a:noFill/>
+          </a:ln>
+        </p:spPr>
+        <p:txBody>
+          <a:bodyPr wrap="square" lIns="182880" tIns="91440" rIns="182880" bIns="91440" anchor="ctr">
+            <a:normAutofit/>
+          </a:bodyPr>
+          <a:lstStyle/>
+          <a:p>
+            <a:pPr algn="r"/>
+            <a:r>
+              <a:rPr lang="en-US" sz="1100" b="1" cap="all" spc="120">
+                <a:solidFill>
+                  <a:srgbClr val="B8B8B8"/>
+                </a:solidFill>
+              </a:rPr>
+              <a:t>4 / 8</a:t>
+            </a:r>
+          </a:p>
+        </p:txBody>
+      </p:sp>
+      <p:sp>
+        <p:nvSpPr>
+          <p:cNvPr id="6" name="Title"/>
+          <p:cNvSpPr txBox="1"/>
+          <p:nvPr/>
+        </p:nvSpPr>
+        <p:spPr>
+          <a:xfrm>
+            <a:off x="685800" y="700000"/>
+            <a:ext cx="10820400" cy="1150000"/>
+          </a:xfrm>
+          <a:prstGeom prst="rect">
+            <a:avLst/>
+          </a:prstGeom>
+          <a:noFill/>
+          <a:ln>
+            <a:noFill/>
+          </a:ln>
+        </p:spPr>
+        <p:txBody>
+          <a:bodyPr wrap="square" lIns="182880" tIns="91440" rIns="182880" bIns="91440" anchor="ctr">
             <a:normAutofit/>
           </a:bodyPr>
           <a:lstStyle/>
@@ -2195,77 +2460,36 @@
               </a:spcAft>
             </a:pPr>
             <a:r>
-              <a:rPr lang="en-US" sz="2500">
-                <a:solidFill>
-                  <a:srgbClr val="F4F5FF"/>
-                </a:solidFill>
-              </a:rPr>
-              <a:t>Choose your Datadog site and sign in with OAuth. Keys are supported, and older manual servers or custom connectors should be removed first.</a:t>
-            </a:r>
-          </a:p>
-        </p:txBody>
-      </p:sp>
-      <p:sp>
-        <p:nvSpPr>
-          <p:cNvPr id="5" name="Accent rule"/>
-          <p:cNvSpPr/>
-          <p:nvPr/>
-        </p:nvSpPr>
-        <p:spPr>
-          <a:xfrm>
-            <a:off x="548640" y="1800000"/>
-            <a:ext cx="45720" cy="3800000"/>
-          </a:xfrm>
-          <a:prstGeom prst="rect">
-            <a:avLst/>
-          </a:prstGeom>
-          <a:solidFill>
-            <a:srgbClr val="9D6CFF"/>
-          </a:solidFill>
-          <a:ln>
-            <a:noFill/>
-          </a:ln>
-        </p:spPr>
-      </p:sp>
-      <p:pic>
-        <p:nvPicPr>
-          <p:cNvPr id="6" name="Asset visual-setup" descr="Setup order: clear conflicts, install, choose a site, sign in. (mermaid diagram)"/>
-          <p:cNvPicPr>
-            <a:picLocks noChangeAspect="1"/>
-          </p:cNvPicPr>
-          <p:nvPr/>
-        </p:nvPicPr>
-        <p:blipFill>
-          <a:blip r:embed="rIdImage1"/>
-          <a:stretch>
-            <a:fillRect/>
-          </a:stretch>
-        </p:blipFill>
-        <p:spPr>
-          <a:xfrm>
-            <a:off x="5000000" y="2021875"/>
-            <a:ext cx="6500000" cy="3656250"/>
-          </a:xfrm>
-          <a:prstGeom prst="rect">
-            <a:avLst/>
-          </a:prstGeom>
-          <a:ln>
-            <a:solidFill>
-              <a:srgbClr val="D9D9D9"/>
-            </a:solidFill>
-          </a:ln>
-        </p:spPr>
-      </p:pic>
-      <p:sp>
-        <p:nvSpPr>
-          <p:cNvPr id="7" name="Footer"/>
-          <p:cNvSpPr txBox="1"/>
-          <p:nvPr/>
-        </p:nvSpPr>
-        <p:spPr>
-          <a:xfrm>
-            <a:off x="685800" y="6250000"/>
-            <a:ext cx="9400000" cy="420000"/>
+              <a:rPr lang="en-US" sz="2900" b="1">
+                <a:solidFill>
+                  <a:srgbClr val="000000"/>
+                </a:solidFill>
+                <a:latin typeface="+mj-lt"/>
+              </a:rPr>
+              <a:t>Set up.</a:t>
+            </a:r>
+            <a:r>
+              <a:rPr lang="en-US" sz="2900" b="1">
+                <a:solidFill>
+                  <a:srgbClr val="632CA6"/>
+                </a:solidFill>
+                <a:latin typeface="+mj-lt"/>
+              </a:rPr>
+              <a:t> Pick a site, sign in.</a:t>
+            </a:r>
+          </a:p>
+        </p:txBody>
+      </p:sp>
+      <p:sp>
+        <p:nvSpPr>
+          <p:cNvPr id="7" name="Body"/>
+          <p:cNvSpPr txBox="1"/>
+          <p:nvPr/>
+        </p:nvSpPr>
+        <p:spPr>
+          <a:xfrm>
+            <a:off x="685800" y="1950000"/>
+            <a:ext cx="3900000" cy="3900000"/>
           </a:xfrm>
           <a:prstGeom prst="rect">
             <a:avLst/>
@@ -2290,26 +2514,77 @@
               </a:spcAft>
             </a:pPr>
             <a:r>
-              <a:rPr lang="en-US" sz="1000">
-                <a:solidFill>
-                  <a:srgbClr val="B3B4BF"/>
-                </a:solidFill>
-              </a:rPr>
-              <a:t>Sources: Set Up the Datadog MCP Server  ·  Datadog Claude Code Plugin</a:t>
-            </a:r>
-          </a:p>
-        </p:txBody>
-      </p:sp>
-      <p:sp>
-        <p:nvSpPr>
-          <p:cNvPr id="8" name="Slide number"/>
-          <p:cNvSpPr txBox="1"/>
-          <p:nvPr/>
-        </p:nvSpPr>
-        <p:spPr>
-          <a:xfrm>
-            <a:off x="10100000" y="6250000"/>
-            <a:ext cx="1400000" cy="420000"/>
+              <a:rPr lang="en-US" sz="2500">
+                <a:solidFill>
+                  <a:srgbClr val="000000"/>
+                </a:solidFill>
+              </a:rPr>
+              <a:t>Choose your Datadog site and sign in with OAuth. Keys are supported, and older manual servers or custom connectors should be removed first.</a:t>
+            </a:r>
+          </a:p>
+        </p:txBody>
+      </p:sp>
+      <p:sp>
+        <p:nvSpPr>
+          <p:cNvPr id="8" name="Accent rule"/>
+          <p:cNvSpPr/>
+          <p:nvPr/>
+        </p:nvSpPr>
+        <p:spPr>
+          <a:xfrm>
+            <a:off x="548640" y="2000000"/>
+            <a:ext cx="45720" cy="3800000"/>
+          </a:xfrm>
+          <a:prstGeom prst="rect">
+            <a:avLst/>
+          </a:prstGeom>
+          <a:solidFill>
+            <a:srgbClr val="632CA6"/>
+          </a:solidFill>
+          <a:ln>
+            <a:noFill/>
+          </a:ln>
+        </p:spPr>
+      </p:sp>
+      <p:pic>
+        <p:nvPicPr>
+          <p:cNvPr id="9" name="Asset visual-setup" descr="Setup order: clear conflicts, install, choose a site, sign in. (mermaid diagram)"/>
+          <p:cNvPicPr>
+            <a:picLocks noChangeAspect="1"/>
+          </p:cNvPicPr>
+          <p:nvPr/>
+        </p:nvPicPr>
+        <p:blipFill>
+          <a:blip r:embed="rIdImage1"/>
+          <a:stretch>
+            <a:fillRect/>
+          </a:stretch>
+        </p:blipFill>
+        <p:spPr>
+          <a:xfrm>
+            <a:off x="5000000" y="2221875"/>
+            <a:ext cx="6500000" cy="3656250"/>
+          </a:xfrm>
+          <a:prstGeom prst="rect">
+            <a:avLst/>
+          </a:prstGeom>
+          <a:ln>
+            <a:solidFill>
+              <a:srgbClr val="D9D9D9"/>
+            </a:solidFill>
+          </a:ln>
+        </p:spPr>
+      </p:pic>
+      <p:sp>
+        <p:nvSpPr>
+          <p:cNvPr id="10" name="Footer"/>
+          <p:cNvSpPr txBox="1"/>
+          <p:nvPr/>
+        </p:nvSpPr>
+        <p:spPr>
+          <a:xfrm>
+            <a:off x="685800" y="6250000"/>
+            <a:ext cx="10820400" cy="420000"/>
           </a:xfrm>
           <a:prstGeom prst="rect">
             <a:avLst/>
@@ -2325,14 +2600,21 @@
           </a:bodyPr>
           <a:lstStyle/>
           <a:p>
-            <a:pPr algn="r"/>
+            <a:pPr algn="l">
+              <a:lnSpc>
+                <a:spcPct val="105000"/>
+              </a:lnSpc>
+              <a:spcAft>
+                <a:spcPts val="0"/>
+              </a:spcAft>
+            </a:pPr>
             <a:r>
               <a:rPr lang="en-US" sz="1000">
                 <a:solidFill>
-                  <a:srgbClr val="B3B4BF"/>
-                </a:solidFill>
-              </a:rPr>
-              <a:t>4 / 8</a:t>
+                  <a:srgbClr val="666666"/>
+                </a:solidFill>
+              </a:rPr>
+              <a:t>Sources: Set Up the Datadog MCP Server  ·  Datadog Claude Code Plugin</a:t>
             </a:r>
           </a:p>
         </p:txBody>
@@ -2351,7 +2633,7 @@
     <p:bg>
       <p:bgPr>
         <a:solidFill>
-          <a:srgbClr val="0B0D1A"/>
+          <a:srgbClr val="F8F6FB"/>
         </a:solidFill>
         <a:effectLst/>
       </p:bgPr>
@@ -2365,20 +2647,20 @@
       <p:grpSpPr/>
       <p:sp>
         <p:nvSpPr>
-          <p:cNvPr id="2" name="Accent band"/>
+          <p:cNvPr id="2" name="Brand band"/>
           <p:cNvSpPr/>
           <p:nvPr/>
         </p:nvSpPr>
         <p:spPr>
           <a:xfrm>
             <a:off x="0" y="0"/>
-            <a:ext cx="12192000" cy="91440"/>
+            <a:ext cx="12192000" cy="502920"/>
           </a:xfrm>
           <a:prstGeom prst="rect">
             <a:avLst/>
           </a:prstGeom>
           <a:solidFill>
-            <a:srgbClr val="9D6CFF"/>
+            <a:srgbClr val="000000"/>
           </a:solidFill>
           <a:ln>
             <a:noFill/>
@@ -2387,14 +2669,36 @@
       </p:sp>
       <p:sp>
         <p:nvSpPr>
-          <p:cNvPr id="3" name="Title"/>
-          <p:cNvSpPr txBox="1"/>
-          <p:nvPr/>
-        </p:nvSpPr>
-        <p:spPr>
-          <a:xfrm>
-            <a:off x="685800" y="420000"/>
-            <a:ext cx="10820400" cy="1150000"/>
+          <p:cNvPr id="3" name="Highlight rule"/>
+          <p:cNvSpPr/>
+          <p:nvPr/>
+        </p:nvSpPr>
+        <p:spPr>
+          <a:xfrm>
+            <a:off x="0" y="502920"/>
+            <a:ext cx="12192000" cy="45720"/>
+          </a:xfrm>
+          <a:prstGeom prst="rect">
+            <a:avLst/>
+          </a:prstGeom>
+          <a:solidFill>
+            <a:srgbClr val="BEAAFF"/>
+          </a:solidFill>
+          <a:ln>
+            <a:noFill/>
+          </a:ln>
+        </p:spPr>
+      </p:sp>
+      <p:sp>
+        <p:nvSpPr>
+          <p:cNvPr id="4" name="Deck kicker"/>
+          <p:cNvSpPr txBox="1"/>
+          <p:nvPr/>
+        </p:nvSpPr>
+        <p:spPr>
+          <a:xfrm>
+            <a:off x="685800" y="0"/>
+            <a:ext cx="8400000" cy="502920"/>
           </a:xfrm>
           <a:prstGeom prst="rect">
             <a:avLst/>
@@ -2419,45 +2723,74 @@
               </a:spcAft>
             </a:pPr>
             <a:r>
-              <a:rPr lang="en-US" sz="2900" b="1">
-                <a:solidFill>
-                  <a:srgbClr val="F4F5FF"/>
-                </a:solidFill>
-              </a:rPr>
-              <a:t>Access.</a:t>
-            </a:r>
-            <a:r>
-              <a:rPr lang="en-US" sz="2900" b="1">
-                <a:solidFill>
-                  <a:srgbClr val="9D6CFF"/>
-                </a:solidFill>
-              </a:rPr>
-              <a:t> Your permissions still apply.</a:t>
-            </a:r>
-          </a:p>
-        </p:txBody>
-      </p:sp>
-      <p:sp>
-        <p:nvSpPr>
-          <p:cNvPr id="4" name="Body"/>
-          <p:cNvSpPr txBox="1"/>
-          <p:nvPr/>
-        </p:nvSpPr>
-        <p:spPr>
-          <a:xfrm>
-            <a:off x="685800" y="1750000"/>
-            <a:ext cx="3900000" cy="3900000"/>
-          </a:xfrm>
-          <a:prstGeom prst="rect">
-            <a:avLst/>
-          </a:prstGeom>
-          <a:noFill/>
-          <a:ln>
-            <a:noFill/>
-          </a:ln>
-        </p:spPr>
-        <p:txBody>
-          <a:bodyPr wrap="square" lIns="182880" tIns="91440" rIns="182880" bIns="91440" anchor="t">
+              <a:rPr lang="en-US" sz="1100" b="1" cap="all" spc="120">
+                <a:solidFill>
+                  <a:srgbClr val="FFFFFF"/>
+                </a:solidFill>
+              </a:rPr>
+              <a:t>Datadog for Claude Cowork</a:t>
+            </a:r>
+          </a:p>
+        </p:txBody>
+      </p:sp>
+      <p:sp>
+        <p:nvSpPr>
+          <p:cNvPr id="5" name="Slide number"/>
+          <p:cNvSpPr txBox="1"/>
+          <p:nvPr/>
+        </p:nvSpPr>
+        <p:spPr>
+          <a:xfrm>
+            <a:off x="9100000" y="0"/>
+            <a:ext cx="2406400" cy="502920"/>
+          </a:xfrm>
+          <a:prstGeom prst="rect">
+            <a:avLst/>
+          </a:prstGeom>
+          <a:noFill/>
+          <a:ln>
+            <a:noFill/>
+          </a:ln>
+        </p:spPr>
+        <p:txBody>
+          <a:bodyPr wrap="square" lIns="182880" tIns="91440" rIns="182880" bIns="91440" anchor="ctr">
+            <a:normAutofit/>
+          </a:bodyPr>
+          <a:lstStyle/>
+          <a:p>
+            <a:pPr algn="r"/>
+            <a:r>
+              <a:rPr lang="en-US" sz="1100" b="1" cap="all" spc="120">
+                <a:solidFill>
+                  <a:srgbClr val="B8B8B8"/>
+                </a:solidFill>
+              </a:rPr>
+              <a:t>5 / 8</a:t>
+            </a:r>
+          </a:p>
+        </p:txBody>
+      </p:sp>
+      <p:sp>
+        <p:nvSpPr>
+          <p:cNvPr id="6" name="Title"/>
+          <p:cNvSpPr txBox="1"/>
+          <p:nvPr/>
+        </p:nvSpPr>
+        <p:spPr>
+          <a:xfrm>
+            <a:off x="685800" y="700000"/>
+            <a:ext cx="10820400" cy="1150000"/>
+          </a:xfrm>
+          <a:prstGeom prst="rect">
+            <a:avLst/>
+          </a:prstGeom>
+          <a:noFill/>
+          <a:ln>
+            <a:noFill/>
+          </a:ln>
+        </p:spPr>
+        <p:txBody>
+          <a:bodyPr wrap="square" lIns="182880" tIns="91440" rIns="182880" bIns="91440" anchor="ctr">
             <a:normAutofit/>
           </a:bodyPr>
           <a:lstStyle/>
@@ -2471,77 +2804,36 @@
               </a:spcAft>
             </a:pPr>
             <a:r>
-              <a:rPr lang="en-US" sz="2600">
-                <a:solidFill>
-                  <a:srgbClr val="F4F5FF"/>
-                </a:solidFill>
-              </a:rPr>
-              <a:t>You need Datadog permissions for the resources you query, and no Datadog credentials are sent to the model provider.</a:t>
-            </a:r>
-          </a:p>
-        </p:txBody>
-      </p:sp>
-      <p:sp>
-        <p:nvSpPr>
-          <p:cNvPr id="5" name="Accent rule"/>
-          <p:cNvSpPr/>
-          <p:nvPr/>
-        </p:nvSpPr>
-        <p:spPr>
-          <a:xfrm>
-            <a:off x="548640" y="1800000"/>
-            <a:ext cx="45720" cy="3800000"/>
-          </a:xfrm>
-          <a:prstGeom prst="rect">
-            <a:avLst/>
-          </a:prstGeom>
-          <a:solidFill>
-            <a:srgbClr val="9D6CFF"/>
-          </a:solidFill>
-          <a:ln>
-            <a:noFill/>
-          </a:ln>
-        </p:spPr>
-      </p:sp>
-      <p:pic>
-        <p:nvPicPr>
-          <p:cNvPr id="6" name="Asset visual-access" descr="Your Datadog permissions apply; no Datadog credentials go to the model provider. (excalidraw diagram)"/>
-          <p:cNvPicPr>
-            <a:picLocks noChangeAspect="1"/>
-          </p:cNvPicPr>
-          <p:nvPr/>
-        </p:nvPicPr>
-        <p:blipFill>
-          <a:blip r:embed="rIdImage1"/>
-          <a:stretch>
-            <a:fillRect/>
-          </a:stretch>
-        </p:blipFill>
-        <p:spPr>
-          <a:xfrm>
-            <a:off x="5000000" y="2021875"/>
-            <a:ext cx="6500000" cy="3656250"/>
-          </a:xfrm>
-          <a:prstGeom prst="rect">
-            <a:avLst/>
-          </a:prstGeom>
-          <a:ln>
-            <a:solidFill>
-              <a:srgbClr val="D9D9D9"/>
-            </a:solidFill>
-          </a:ln>
-        </p:spPr>
-      </p:pic>
-      <p:sp>
-        <p:nvSpPr>
-          <p:cNvPr id="7" name="Footer"/>
-          <p:cNvSpPr txBox="1"/>
-          <p:nvPr/>
-        </p:nvSpPr>
-        <p:spPr>
-          <a:xfrm>
-            <a:off x="685800" y="6250000"/>
-            <a:ext cx="9400000" cy="420000"/>
+              <a:rPr lang="en-US" sz="2900" b="1">
+                <a:solidFill>
+                  <a:srgbClr val="000000"/>
+                </a:solidFill>
+                <a:latin typeface="+mj-lt"/>
+              </a:rPr>
+              <a:t>Access.</a:t>
+            </a:r>
+            <a:r>
+              <a:rPr lang="en-US" sz="2900" b="1">
+                <a:solidFill>
+                  <a:srgbClr val="632CA6"/>
+                </a:solidFill>
+                <a:latin typeface="+mj-lt"/>
+              </a:rPr>
+              <a:t> Your permissions still apply.</a:t>
+            </a:r>
+          </a:p>
+        </p:txBody>
+      </p:sp>
+      <p:sp>
+        <p:nvSpPr>
+          <p:cNvPr id="7" name="Body"/>
+          <p:cNvSpPr txBox="1"/>
+          <p:nvPr/>
+        </p:nvSpPr>
+        <p:spPr>
+          <a:xfrm>
+            <a:off x="685800" y="1950000"/>
+            <a:ext cx="3900000" cy="3900000"/>
           </a:xfrm>
           <a:prstGeom prst="rect">
             <a:avLst/>
@@ -2566,26 +2858,77 @@
               </a:spcAft>
             </a:pPr>
             <a:r>
-              <a:rPr lang="en-US" sz="1000">
-                <a:solidFill>
-                  <a:srgbClr val="B3B4BF"/>
-                </a:solidFill>
-              </a:rPr>
-              <a:t>Sources: Set Up the Datadog MCP Server  ·  Datadog Claude Code Plugin</a:t>
-            </a:r>
-          </a:p>
-        </p:txBody>
-      </p:sp>
-      <p:sp>
-        <p:nvSpPr>
-          <p:cNvPr id="8" name="Slide number"/>
-          <p:cNvSpPr txBox="1"/>
-          <p:nvPr/>
-        </p:nvSpPr>
-        <p:spPr>
-          <a:xfrm>
-            <a:off x="10100000" y="6250000"/>
-            <a:ext cx="1400000" cy="420000"/>
+              <a:rPr lang="en-US" sz="2600">
+                <a:solidFill>
+                  <a:srgbClr val="000000"/>
+                </a:solidFill>
+              </a:rPr>
+              <a:t>You need Datadog permissions for the resources you query, and no Datadog credentials are sent to the model provider.</a:t>
+            </a:r>
+          </a:p>
+        </p:txBody>
+      </p:sp>
+      <p:sp>
+        <p:nvSpPr>
+          <p:cNvPr id="8" name="Accent rule"/>
+          <p:cNvSpPr/>
+          <p:nvPr/>
+        </p:nvSpPr>
+        <p:spPr>
+          <a:xfrm>
+            <a:off x="548640" y="2000000"/>
+            <a:ext cx="45720" cy="3800000"/>
+          </a:xfrm>
+          <a:prstGeom prst="rect">
+            <a:avLst/>
+          </a:prstGeom>
+          <a:solidFill>
+            <a:srgbClr val="632CA6"/>
+          </a:solidFill>
+          <a:ln>
+            <a:noFill/>
+          </a:ln>
+        </p:spPr>
+      </p:sp>
+      <p:pic>
+        <p:nvPicPr>
+          <p:cNvPr id="9" name="Asset visual-access" descr="Your Datadog permissions apply; no Datadog credentials go to the model provider. (excalidraw diagram)"/>
+          <p:cNvPicPr>
+            <a:picLocks noChangeAspect="1"/>
+          </p:cNvPicPr>
+          <p:nvPr/>
+        </p:nvPicPr>
+        <p:blipFill>
+          <a:blip r:embed="rIdImage1"/>
+          <a:stretch>
+            <a:fillRect/>
+          </a:stretch>
+        </p:blipFill>
+        <p:spPr>
+          <a:xfrm>
+            <a:off x="5000000" y="2221875"/>
+            <a:ext cx="6500000" cy="3656250"/>
+          </a:xfrm>
+          <a:prstGeom prst="rect">
+            <a:avLst/>
+          </a:prstGeom>
+          <a:ln>
+            <a:solidFill>
+              <a:srgbClr val="D9D9D9"/>
+            </a:solidFill>
+          </a:ln>
+        </p:spPr>
+      </p:pic>
+      <p:sp>
+        <p:nvSpPr>
+          <p:cNvPr id="10" name="Footer"/>
+          <p:cNvSpPr txBox="1"/>
+          <p:nvPr/>
+        </p:nvSpPr>
+        <p:spPr>
+          <a:xfrm>
+            <a:off x="685800" y="6250000"/>
+            <a:ext cx="10820400" cy="420000"/>
           </a:xfrm>
           <a:prstGeom prst="rect">
             <a:avLst/>
@@ -2601,14 +2944,21 @@
           </a:bodyPr>
           <a:lstStyle/>
           <a:p>
-            <a:pPr algn="r"/>
+            <a:pPr algn="l">
+              <a:lnSpc>
+                <a:spcPct val="105000"/>
+              </a:lnSpc>
+              <a:spcAft>
+                <a:spcPts val="0"/>
+              </a:spcAft>
+            </a:pPr>
             <a:r>
               <a:rPr lang="en-US" sz="1000">
                 <a:solidFill>
-                  <a:srgbClr val="B3B4BF"/>
-                </a:solidFill>
-              </a:rPr>
-              <a:t>5 / 8</a:t>
+                  <a:srgbClr val="666666"/>
+                </a:solidFill>
+              </a:rPr>
+              <a:t>Sources: Set Up the Datadog MCP Server  ·  Datadog Claude Code Plugin</a:t>
             </a:r>
           </a:p>
         </p:txBody>
@@ -2627,7 +2977,7 @@
     <p:bg>
       <p:bgPr>
         <a:solidFill>
-          <a:srgbClr val="0B0D1A"/>
+          <a:srgbClr val="F8F6FB"/>
         </a:solidFill>
         <a:effectLst/>
       </p:bgPr>
@@ -2641,20 +2991,20 @@
       <p:grpSpPr/>
       <p:sp>
         <p:nvSpPr>
-          <p:cNvPr id="2" name="Accent band"/>
+          <p:cNvPr id="2" name="Brand band"/>
           <p:cNvSpPr/>
           <p:nvPr/>
         </p:nvSpPr>
         <p:spPr>
           <a:xfrm>
             <a:off x="0" y="0"/>
-            <a:ext cx="12192000" cy="91440"/>
+            <a:ext cx="12192000" cy="502920"/>
           </a:xfrm>
           <a:prstGeom prst="rect">
             <a:avLst/>
           </a:prstGeom>
           <a:solidFill>
-            <a:srgbClr val="9D6CFF"/>
+            <a:srgbClr val="000000"/>
           </a:solidFill>
           <a:ln>
             <a:noFill/>
@@ -2663,14 +3013,36 @@
       </p:sp>
       <p:sp>
         <p:nvSpPr>
-          <p:cNvPr id="3" name="Title"/>
-          <p:cNvSpPr txBox="1"/>
-          <p:nvPr/>
-        </p:nvSpPr>
-        <p:spPr>
-          <a:xfrm>
-            <a:off x="685800" y="420000"/>
-            <a:ext cx="10820400" cy="1150000"/>
+          <p:cNvPr id="3" name="Highlight rule"/>
+          <p:cNvSpPr/>
+          <p:nvPr/>
+        </p:nvSpPr>
+        <p:spPr>
+          <a:xfrm>
+            <a:off x="0" y="502920"/>
+            <a:ext cx="12192000" cy="45720"/>
+          </a:xfrm>
+          <a:prstGeom prst="rect">
+            <a:avLst/>
+          </a:prstGeom>
+          <a:solidFill>
+            <a:srgbClr val="BEAAFF"/>
+          </a:solidFill>
+          <a:ln>
+            <a:noFill/>
+          </a:ln>
+        </p:spPr>
+      </p:sp>
+      <p:sp>
+        <p:nvSpPr>
+          <p:cNvPr id="4" name="Deck kicker"/>
+          <p:cNvSpPr txBox="1"/>
+          <p:nvPr/>
+        </p:nvSpPr>
+        <p:spPr>
+          <a:xfrm>
+            <a:off x="685800" y="0"/>
+            <a:ext cx="8400000" cy="502920"/>
           </a:xfrm>
           <a:prstGeom prst="rect">
             <a:avLst/>
@@ -2695,45 +3067,74 @@
               </a:spcAft>
             </a:pPr>
             <a:r>
-              <a:rPr lang="en-US" sz="2900" b="1">
-                <a:solidFill>
-                  <a:srgbClr val="F4F5FF"/>
-                </a:solidFill>
-              </a:rPr>
-              <a:t>Control.</a:t>
-            </a:r>
-            <a:r>
-              <a:rPr lang="en-US" sz="2900" b="1">
-                <a:solidFill>
-                  <a:srgbClr val="9D6CFF"/>
-                </a:solidFill>
-              </a:rPr>
-              <a:t> Choose the toolsets.</a:t>
-            </a:r>
-          </a:p>
-        </p:txBody>
-      </p:sp>
-      <p:sp>
-        <p:nvSpPr>
-          <p:cNvPr id="4" name="Body"/>
-          <p:cNvSpPr txBox="1"/>
-          <p:nvPr/>
-        </p:nvSpPr>
-        <p:spPr>
-          <a:xfrm>
-            <a:off x="685800" y="1750000"/>
-            <a:ext cx="5300000" cy="3900000"/>
-          </a:xfrm>
-          <a:prstGeom prst="rect">
-            <a:avLst/>
-          </a:prstGeom>
-          <a:noFill/>
-          <a:ln>
-            <a:noFill/>
-          </a:ln>
-        </p:spPr>
-        <p:txBody>
-          <a:bodyPr wrap="square" lIns="182880" tIns="91440" rIns="182880" bIns="91440" anchor="t">
+              <a:rPr lang="en-US" sz="1100" b="1" cap="all" spc="120">
+                <a:solidFill>
+                  <a:srgbClr val="FFFFFF"/>
+                </a:solidFill>
+              </a:rPr>
+              <a:t>Datadog for Claude Cowork</a:t>
+            </a:r>
+          </a:p>
+        </p:txBody>
+      </p:sp>
+      <p:sp>
+        <p:nvSpPr>
+          <p:cNvPr id="5" name="Slide number"/>
+          <p:cNvSpPr txBox="1"/>
+          <p:nvPr/>
+        </p:nvSpPr>
+        <p:spPr>
+          <a:xfrm>
+            <a:off x="9100000" y="0"/>
+            <a:ext cx="2406400" cy="502920"/>
+          </a:xfrm>
+          <a:prstGeom prst="rect">
+            <a:avLst/>
+          </a:prstGeom>
+          <a:noFill/>
+          <a:ln>
+            <a:noFill/>
+          </a:ln>
+        </p:spPr>
+        <p:txBody>
+          <a:bodyPr wrap="square" lIns="182880" tIns="91440" rIns="182880" bIns="91440" anchor="ctr">
+            <a:normAutofit/>
+          </a:bodyPr>
+          <a:lstStyle/>
+          <a:p>
+            <a:pPr algn="r"/>
+            <a:r>
+              <a:rPr lang="en-US" sz="1100" b="1" cap="all" spc="120">
+                <a:solidFill>
+                  <a:srgbClr val="B8B8B8"/>
+                </a:solidFill>
+              </a:rPr>
+              <a:t>6 / 8</a:t>
+            </a:r>
+          </a:p>
+        </p:txBody>
+      </p:sp>
+      <p:sp>
+        <p:nvSpPr>
+          <p:cNvPr id="6" name="Title"/>
+          <p:cNvSpPr txBox="1"/>
+          <p:nvPr/>
+        </p:nvSpPr>
+        <p:spPr>
+          <a:xfrm>
+            <a:off x="685800" y="700000"/>
+            <a:ext cx="10820400" cy="1150000"/>
+          </a:xfrm>
+          <a:prstGeom prst="rect">
+            <a:avLst/>
+          </a:prstGeom>
+          <a:noFill/>
+          <a:ln>
+            <a:noFill/>
+          </a:ln>
+        </p:spPr>
+        <p:txBody>
+          <a:bodyPr wrap="square" lIns="182880" tIns="91440" rIns="182880" bIns="91440" anchor="ctr">
             <a:normAutofit/>
           </a:bodyPr>
           <a:lstStyle/>
@@ -2747,9 +3148,63 @@
               </a:spcAft>
             </a:pPr>
             <a:r>
+              <a:rPr lang="en-US" sz="2900" b="1">
+                <a:solidFill>
+                  <a:srgbClr val="000000"/>
+                </a:solidFill>
+                <a:latin typeface="+mj-lt"/>
+              </a:rPr>
+              <a:t>Control.</a:t>
+            </a:r>
+            <a:r>
+              <a:rPr lang="en-US" sz="2900" b="1">
+                <a:solidFill>
+                  <a:srgbClr val="632CA6"/>
+                </a:solidFill>
+                <a:latin typeface="+mj-lt"/>
+              </a:rPr>
+              <a:t> Choose the toolsets.</a:t>
+            </a:r>
+          </a:p>
+        </p:txBody>
+      </p:sp>
+      <p:sp>
+        <p:nvSpPr>
+          <p:cNvPr id="7" name="Body"/>
+          <p:cNvSpPr txBox="1"/>
+          <p:nvPr/>
+        </p:nvSpPr>
+        <p:spPr>
+          <a:xfrm>
+            <a:off x="685800" y="1950000"/>
+            <a:ext cx="5300000" cy="3900000"/>
+          </a:xfrm>
+          <a:prstGeom prst="rect">
+            <a:avLst/>
+          </a:prstGeom>
+          <a:noFill/>
+          <a:ln>
+            <a:noFill/>
+          </a:ln>
+        </p:spPr>
+        <p:txBody>
+          <a:bodyPr wrap="square" lIns="182880" tIns="91440" rIns="182880" bIns="91440" anchor="t">
+            <a:normAutofit/>
+          </a:bodyPr>
+          <a:lstStyle/>
+          <a:p>
+            <a:pPr algn="l">
+              <a:lnSpc>
+                <a:spcPct val="105000"/>
+              </a:lnSpc>
+              <a:spcAft>
+                <a:spcPts val="0"/>
+              </a:spcAft>
+            </a:pPr>
+            <a:r>
               <a:rPr lang="en-US" sz="2600">
                 <a:solidFill>
-                  <a:srgbClr val="F4F5FF"/>
+                  <a:srgbClr val="000000"/>
                 </a:solidFill>
               </a:rPr>
               <a:t>Enable or disable groups of MCP tools so the agent sees only the Datadog products your team needs.</a:t>
@@ -2759,20 +3214,20 @@
       </p:sp>
       <p:sp>
         <p:nvSpPr>
-          <p:cNvPr id="5" name="Accent rule"/>
+          <p:cNvPr id="8" name="Accent rule"/>
           <p:cNvSpPr/>
           <p:nvPr/>
         </p:nvSpPr>
         <p:spPr>
           <a:xfrm>
-            <a:off x="548640" y="1800000"/>
+            <a:off x="548640" y="2000000"/>
             <a:ext cx="45720" cy="3800000"/>
           </a:xfrm>
           <a:prstGeom prst="rect">
             <a:avLst/>
           </a:prstGeom>
           <a:solidFill>
-            <a:srgbClr val="9D6CFF"/>
+            <a:srgbClr val="632CA6"/>
           </a:solidFill>
           <a:ln>
             <a:noFill/>
@@ -2781,26 +3236,26 @@
       </p:sp>
       <p:sp>
         <p:nvSpPr>
-          <p:cNvPr id="6" name="Claim 1"/>
+          <p:cNvPr id="9" name="Claim 1"/>
           <p:cNvSpPr/>
           <p:nvPr/>
         </p:nvSpPr>
         <p:spPr>
           <a:xfrm>
-            <a:off x="6400000" y="1750000"/>
+            <a:off x="6400000" y="1950000"/>
             <a:ext cx="5105000" cy="1500000"/>
           </a:xfrm>
           <a:prstGeom prst="roundRect">
             <a:avLst>
-              <a:gd name="adj" fmla="val 9000"/>
+              <a:gd name="adj" fmla="val 6000"/>
             </a:avLst>
           </a:prstGeom>
           <a:solidFill>
-            <a:srgbClr val="1E202C"/>
+            <a:srgbClr val="FFFFFF"/>
           </a:solidFill>
           <a:ln w="12700">
             <a:solidFill>
-              <a:srgbClr val="353743"/>
+              <a:srgbClr val="D4CBDF"/>
             </a:solidFill>
           </a:ln>
         </p:spPr>
@@ -2821,7 +3276,7 @@
             <a:r>
               <a:rPr lang="en-US" sz="1800">
                 <a:solidFill>
-                  <a:srgbClr val="F4F5FF"/>
+                  <a:srgbClr val="000000"/>
                 </a:solidFill>
               </a:rPr>
               <a:t>Groups of MCP tools can be enabled or disabled with the toolsets command.</a:t>
@@ -2839,7 +3294,7 @@
             <a:r>
               <a:rPr lang="en-US" sz="1100">
                 <a:solidFill>
-                  <a:srgbClr val="B3B4BF"/>
+                  <a:srgbClr val="666666"/>
                 </a:solidFill>
               </a:rPr>
               <a:t>Datadog Claude Code Plugin</a:t>
@@ -2849,14 +3304,14 @@
       </p:sp>
       <p:sp>
         <p:nvSpPr>
-          <p:cNvPr id="7" name="Footer"/>
+          <p:cNvPr id="10" name="Footer"/>
           <p:cNvSpPr txBox="1"/>
           <p:nvPr/>
         </p:nvSpPr>
         <p:spPr>
           <a:xfrm>
             <a:off x="685800" y="6250000"/>
-            <a:ext cx="9400000" cy="420000"/>
+            <a:ext cx="10820400" cy="420000"/>
           </a:xfrm>
           <a:prstGeom prst="rect">
             <a:avLst/>
@@ -2883,47 +3338,10 @@
             <a:r>
               <a:rPr lang="en-US" sz="1000">
                 <a:solidFill>
-                  <a:srgbClr val="B3B4BF"/>
+                  <a:srgbClr val="666666"/>
                 </a:solidFill>
               </a:rPr>
               <a:t>Sources: Datadog Claude Code Plugin</a:t>
-            </a:r>
-          </a:p>
-        </p:txBody>
-      </p:sp>
-      <p:sp>
-        <p:nvSpPr>
-          <p:cNvPr id="8" name="Slide number"/>
-          <p:cNvSpPr txBox="1"/>
-          <p:nvPr/>
-        </p:nvSpPr>
-        <p:spPr>
-          <a:xfrm>
-            <a:off x="10100000" y="6250000"/>
-            <a:ext cx="1400000" cy="420000"/>
-          </a:xfrm>
-          <a:prstGeom prst="rect">
-            <a:avLst/>
-          </a:prstGeom>
-          <a:noFill/>
-          <a:ln>
-            <a:noFill/>
-          </a:ln>
-        </p:spPr>
-        <p:txBody>
-          <a:bodyPr wrap="square" lIns="182880" tIns="91440" rIns="182880" bIns="91440" anchor="t">
-            <a:normAutofit/>
-          </a:bodyPr>
-          <a:lstStyle/>
-          <a:p>
-            <a:pPr algn="r"/>
-            <a:r>
-              <a:rPr lang="en-US" sz="1000">
-                <a:solidFill>
-                  <a:srgbClr val="B3B4BF"/>
-                </a:solidFill>
-              </a:rPr>
-              <a:t>6 / 8</a:t>
             </a:r>
           </a:p>
         </p:txBody>
@@ -2942,7 +3360,7 @@
     <p:bg>
       <p:bgPr>
         <a:solidFill>
-          <a:srgbClr val="0B0D1A"/>
+          <a:srgbClr val="F8F6FB"/>
         </a:solidFill>
         <a:effectLst/>
       </p:bgPr>
@@ -2956,20 +3374,20 @@
       <p:grpSpPr/>
       <p:sp>
         <p:nvSpPr>
-          <p:cNvPr id="2" name="Accent band"/>
+          <p:cNvPr id="2" name="Brand band"/>
           <p:cNvSpPr/>
           <p:nvPr/>
         </p:nvSpPr>
         <p:spPr>
           <a:xfrm>
             <a:off x="0" y="0"/>
-            <a:ext cx="12192000" cy="91440"/>
+            <a:ext cx="12192000" cy="502920"/>
           </a:xfrm>
           <a:prstGeom prst="rect">
             <a:avLst/>
           </a:prstGeom>
           <a:solidFill>
-            <a:srgbClr val="9D6CFF"/>
+            <a:srgbClr val="000000"/>
           </a:solidFill>
           <a:ln>
             <a:noFill/>
@@ -2978,14 +3396,36 @@
       </p:sp>
       <p:sp>
         <p:nvSpPr>
-          <p:cNvPr id="3" name="Title"/>
-          <p:cNvSpPr txBox="1"/>
-          <p:nvPr/>
-        </p:nvSpPr>
-        <p:spPr>
-          <a:xfrm>
-            <a:off x="685800" y="420000"/>
-            <a:ext cx="10820400" cy="1150000"/>
+          <p:cNvPr id="3" name="Highlight rule"/>
+          <p:cNvSpPr/>
+          <p:nvPr/>
+        </p:nvSpPr>
+        <p:spPr>
+          <a:xfrm>
+            <a:off x="0" y="502920"/>
+            <a:ext cx="12192000" cy="45720"/>
+          </a:xfrm>
+          <a:prstGeom prst="rect">
+            <a:avLst/>
+          </a:prstGeom>
+          <a:solidFill>
+            <a:srgbClr val="BEAAFF"/>
+          </a:solidFill>
+          <a:ln>
+            <a:noFill/>
+          </a:ln>
+        </p:spPr>
+      </p:sp>
+      <p:sp>
+        <p:nvSpPr>
+          <p:cNvPr id="4" name="Deck kicker"/>
+          <p:cNvSpPr txBox="1"/>
+          <p:nvPr/>
+        </p:nvSpPr>
+        <p:spPr>
+          <a:xfrm>
+            <a:off x="685800" y="0"/>
+            <a:ext cx="8400000" cy="502920"/>
           </a:xfrm>
           <a:prstGeom prst="rect">
             <a:avLst/>
@@ -3010,45 +3450,74 @@
               </a:spcAft>
             </a:pPr>
             <a:r>
-              <a:rPr lang="en-US" sz="2900" b="1">
-                <a:solidFill>
-                  <a:srgbClr val="F4F5FF"/>
-                </a:solidFill>
-              </a:rPr>
-              <a:t>Risk.</a:t>
-            </a:r>
-            <a:r>
-              <a:rPr lang="en-US" sz="2900" b="1">
-                <a:solidFill>
-                  <a:srgbClr val="9D6CFF"/>
-                </a:solidFill>
-              </a:rPr>
-              <a:t> Preview, compliance, site limits.</a:t>
-            </a:r>
-          </a:p>
-        </p:txBody>
-      </p:sp>
-      <p:sp>
-        <p:nvSpPr>
-          <p:cNvPr id="4" name="Body"/>
-          <p:cNvSpPr txBox="1"/>
-          <p:nvPr/>
-        </p:nvSpPr>
-        <p:spPr>
-          <a:xfrm>
-            <a:off x="685800" y="1750000"/>
-            <a:ext cx="3900000" cy="3900000"/>
-          </a:xfrm>
-          <a:prstGeom prst="rect">
-            <a:avLst/>
-          </a:prstGeom>
-          <a:noFill/>
-          <a:ln>
-            <a:noFill/>
-          </a:ln>
-        </p:spPr>
-        <p:txBody>
-          <a:bodyPr wrap="square" lIns="182880" tIns="91440" rIns="182880" bIns="91440" anchor="t">
+              <a:rPr lang="en-US" sz="1100" b="1" cap="all" spc="120">
+                <a:solidFill>
+                  <a:srgbClr val="FFFFFF"/>
+                </a:solidFill>
+              </a:rPr>
+              <a:t>Datadog for Claude Cowork</a:t>
+            </a:r>
+          </a:p>
+        </p:txBody>
+      </p:sp>
+      <p:sp>
+        <p:nvSpPr>
+          <p:cNvPr id="5" name="Slide number"/>
+          <p:cNvSpPr txBox="1"/>
+          <p:nvPr/>
+        </p:nvSpPr>
+        <p:spPr>
+          <a:xfrm>
+            <a:off x="9100000" y="0"/>
+            <a:ext cx="2406400" cy="502920"/>
+          </a:xfrm>
+          <a:prstGeom prst="rect">
+            <a:avLst/>
+          </a:prstGeom>
+          <a:noFill/>
+          <a:ln>
+            <a:noFill/>
+          </a:ln>
+        </p:spPr>
+        <p:txBody>
+          <a:bodyPr wrap="square" lIns="182880" tIns="91440" rIns="182880" bIns="91440" anchor="ctr">
+            <a:normAutofit/>
+          </a:bodyPr>
+          <a:lstStyle/>
+          <a:p>
+            <a:pPr algn="r"/>
+            <a:r>
+              <a:rPr lang="en-US" sz="1100" b="1" cap="all" spc="120">
+                <a:solidFill>
+                  <a:srgbClr val="B8B8B8"/>
+                </a:solidFill>
+              </a:rPr>
+              <a:t>7 / 8</a:t>
+            </a:r>
+          </a:p>
+        </p:txBody>
+      </p:sp>
+      <p:sp>
+        <p:nvSpPr>
+          <p:cNvPr id="6" name="Title"/>
+          <p:cNvSpPr txBox="1"/>
+          <p:nvPr/>
+        </p:nvSpPr>
+        <p:spPr>
+          <a:xfrm>
+            <a:off x="685800" y="700000"/>
+            <a:ext cx="10820400" cy="1150000"/>
+          </a:xfrm>
+          <a:prstGeom prst="rect">
+            <a:avLst/>
+          </a:prstGeom>
+          <a:noFill/>
+          <a:ln>
+            <a:noFill/>
+          </a:ln>
+        </p:spPr>
+        <p:txBody>
+          <a:bodyPr wrap="square" lIns="182880" tIns="91440" rIns="182880" bIns="91440" anchor="ctr">
             <a:normAutofit/>
           </a:bodyPr>
           <a:lstStyle/>
@@ -3062,77 +3531,36 @@
               </a:spcAft>
             </a:pPr>
             <a:r>
-              <a:rPr lang="en-US" sz="2500">
-                <a:solidFill>
-                  <a:srgbClr val="F4F5FF"/>
-                </a:solidFill>
-              </a:rPr>
-              <a:t>The plugin is in Preview. The server is HIPAA-eligible, but you own compliance for connected tools, and the government sites are unsupported.</a:t>
-            </a:r>
-          </a:p>
-        </p:txBody>
-      </p:sp>
-      <p:sp>
-        <p:nvSpPr>
-          <p:cNvPr id="5" name="Accent rule"/>
-          <p:cNvSpPr/>
-          <p:nvPr/>
-        </p:nvSpPr>
-        <p:spPr>
-          <a:xfrm>
-            <a:off x="548640" y="1800000"/>
-            <a:ext cx="45720" cy="3800000"/>
-          </a:xfrm>
-          <a:prstGeom prst="rect">
-            <a:avLst/>
-          </a:prstGeom>
-          <a:solidFill>
-            <a:srgbClr val="9D6CFF"/>
-          </a:solidFill>
-          <a:ln>
-            <a:noFill/>
-          </a:ln>
-        </p:spPr>
-      </p:sp>
-      <p:pic>
-        <p:nvPicPr>
-          <p:cNvPr id="6" name="Asset visual-risk" descr="Rollout checklist: Preview status, compliance ownership and supported sites. (marp diagram)"/>
-          <p:cNvPicPr>
-            <a:picLocks noChangeAspect="1"/>
-          </p:cNvPicPr>
-          <p:nvPr/>
-        </p:nvPicPr>
-        <p:blipFill>
-          <a:blip r:embed="rIdImage1"/>
-          <a:stretch>
-            <a:fillRect/>
-          </a:stretch>
-        </p:blipFill>
-        <p:spPr>
-          <a:xfrm>
-            <a:off x="5000000" y="2021875"/>
-            <a:ext cx="6500000" cy="3656250"/>
-          </a:xfrm>
-          <a:prstGeom prst="rect">
-            <a:avLst/>
-          </a:prstGeom>
-          <a:ln>
-            <a:solidFill>
-              <a:srgbClr val="D9D9D9"/>
-            </a:solidFill>
-          </a:ln>
-        </p:spPr>
-      </p:pic>
-      <p:sp>
-        <p:nvSpPr>
-          <p:cNvPr id="7" name="Footer"/>
-          <p:cNvSpPr txBox="1"/>
-          <p:nvPr/>
-        </p:nvSpPr>
-        <p:spPr>
-          <a:xfrm>
-            <a:off x="685800" y="6250000"/>
-            <a:ext cx="9400000" cy="420000"/>
+              <a:rPr lang="en-US" sz="2900" b="1">
+                <a:solidFill>
+                  <a:srgbClr val="000000"/>
+                </a:solidFill>
+                <a:latin typeface="+mj-lt"/>
+              </a:rPr>
+              <a:t>Risk.</a:t>
+            </a:r>
+            <a:r>
+              <a:rPr lang="en-US" sz="2900" b="1">
+                <a:solidFill>
+                  <a:srgbClr val="632CA6"/>
+                </a:solidFill>
+                <a:latin typeface="+mj-lt"/>
+              </a:rPr>
+              <a:t> Preview, compliance, site limits.</a:t>
+            </a:r>
+          </a:p>
+        </p:txBody>
+      </p:sp>
+      <p:sp>
+        <p:nvSpPr>
+          <p:cNvPr id="7" name="Body"/>
+          <p:cNvSpPr txBox="1"/>
+          <p:nvPr/>
+        </p:nvSpPr>
+        <p:spPr>
+          <a:xfrm>
+            <a:off x="685800" y="1950000"/>
+            <a:ext cx="3900000" cy="3900000"/>
           </a:xfrm>
           <a:prstGeom prst="rect">
             <a:avLst/>
@@ -3157,26 +3585,77 @@
               </a:spcAft>
             </a:pPr>
             <a:r>
-              <a:rPr lang="en-US" sz="1000">
-                <a:solidFill>
-                  <a:srgbClr val="B3B4BF"/>
-                </a:solidFill>
-              </a:rPr>
-              <a:t>Sources: Datadog Claude Code Plugin  ·  Datadog | Claude by Anthropic  ·  Datadog MCP Server  ·  +1 more</a:t>
-            </a:r>
-          </a:p>
-        </p:txBody>
-      </p:sp>
-      <p:sp>
-        <p:nvSpPr>
-          <p:cNvPr id="8" name="Slide number"/>
-          <p:cNvSpPr txBox="1"/>
-          <p:nvPr/>
-        </p:nvSpPr>
-        <p:spPr>
-          <a:xfrm>
-            <a:off x="10100000" y="6250000"/>
-            <a:ext cx="1400000" cy="420000"/>
+              <a:rPr lang="en-US" sz="2500">
+                <a:solidFill>
+                  <a:srgbClr val="000000"/>
+                </a:solidFill>
+              </a:rPr>
+              <a:t>The plugin is in Preview. The server is HIPAA-eligible, but you own compliance for connected tools, and the government sites are unsupported.</a:t>
+            </a:r>
+          </a:p>
+        </p:txBody>
+      </p:sp>
+      <p:sp>
+        <p:nvSpPr>
+          <p:cNvPr id="8" name="Accent rule"/>
+          <p:cNvSpPr/>
+          <p:nvPr/>
+        </p:nvSpPr>
+        <p:spPr>
+          <a:xfrm>
+            <a:off x="548640" y="2000000"/>
+            <a:ext cx="45720" cy="3800000"/>
+          </a:xfrm>
+          <a:prstGeom prst="rect">
+            <a:avLst/>
+          </a:prstGeom>
+          <a:solidFill>
+            <a:srgbClr val="632CA6"/>
+          </a:solidFill>
+          <a:ln>
+            <a:noFill/>
+          </a:ln>
+        </p:spPr>
+      </p:sp>
+      <p:pic>
+        <p:nvPicPr>
+          <p:cNvPr id="9" name="Asset visual-risk" descr="Rollout checklist: Preview status, compliance ownership and supported sites. (marp diagram)"/>
+          <p:cNvPicPr>
+            <a:picLocks noChangeAspect="1"/>
+          </p:cNvPicPr>
+          <p:nvPr/>
+        </p:nvPicPr>
+        <p:blipFill>
+          <a:blip r:embed="rIdImage1"/>
+          <a:stretch>
+            <a:fillRect/>
+          </a:stretch>
+        </p:blipFill>
+        <p:spPr>
+          <a:xfrm>
+            <a:off x="5000000" y="2221875"/>
+            <a:ext cx="6500000" cy="3656250"/>
+          </a:xfrm>
+          <a:prstGeom prst="rect">
+            <a:avLst/>
+          </a:prstGeom>
+          <a:ln>
+            <a:solidFill>
+              <a:srgbClr val="D9D9D9"/>
+            </a:solidFill>
+          </a:ln>
+        </p:spPr>
+      </p:pic>
+      <p:sp>
+        <p:nvSpPr>
+          <p:cNvPr id="10" name="Footer"/>
+          <p:cNvSpPr txBox="1"/>
+          <p:nvPr/>
+        </p:nvSpPr>
+        <p:spPr>
+          <a:xfrm>
+            <a:off x="685800" y="6250000"/>
+            <a:ext cx="10820400" cy="420000"/>
           </a:xfrm>
           <a:prstGeom prst="rect">
             <a:avLst/>
@@ -3192,14 +3671,21 @@
           </a:bodyPr>
           <a:lstStyle/>
           <a:p>
-            <a:pPr algn="r"/>
+            <a:pPr algn="l">
+              <a:lnSpc>
+                <a:spcPct val="105000"/>
+              </a:lnSpc>
+              <a:spcAft>
+                <a:spcPts val="0"/>
+              </a:spcAft>
+            </a:pPr>
             <a:r>
               <a:rPr lang="en-US" sz="1000">
                 <a:solidFill>
-                  <a:srgbClr val="B3B4BF"/>
-                </a:solidFill>
-              </a:rPr>
-              <a:t>7 / 8</a:t>
+                  <a:srgbClr val="666666"/>
+                </a:solidFill>
+              </a:rPr>
+              <a:t>Sources: Datadog Claude Code Plugin  ·  Datadog | Claude by Anthropic  ·  Datadog MCP Server  ·  +1 more</a:t>
             </a:r>
           </a:p>
         </p:txBody>
@@ -3218,7 +3704,7 @@
     <p:bg>
       <p:bgPr>
         <a:solidFill>
-          <a:srgbClr val="0B0D1A"/>
+          <a:srgbClr val="F8F6FB"/>
         </a:solidFill>
         <a:effectLst/>
       </p:bgPr>
@@ -3232,20 +3718,20 @@
       <p:grpSpPr/>
       <p:sp>
         <p:nvSpPr>
-          <p:cNvPr id="2" name="Accent band"/>
+          <p:cNvPr id="2" name="Brand band"/>
           <p:cNvSpPr/>
           <p:nvPr/>
         </p:nvSpPr>
         <p:spPr>
           <a:xfrm>
             <a:off x="0" y="0"/>
-            <a:ext cx="12192000" cy="91440"/>
+            <a:ext cx="12192000" cy="502920"/>
           </a:xfrm>
           <a:prstGeom prst="rect">
             <a:avLst/>
           </a:prstGeom>
           <a:solidFill>
-            <a:srgbClr val="9D6CFF"/>
+            <a:srgbClr val="000000"/>
           </a:solidFill>
           <a:ln>
             <a:noFill/>
@@ -3254,14 +3740,36 @@
       </p:sp>
       <p:sp>
         <p:nvSpPr>
-          <p:cNvPr id="3" name="Title"/>
-          <p:cNvSpPr txBox="1"/>
-          <p:nvPr/>
-        </p:nvSpPr>
-        <p:spPr>
-          <a:xfrm>
-            <a:off x="685800" y="420000"/>
-            <a:ext cx="10820400" cy="1000000"/>
+          <p:cNvPr id="3" name="Highlight rule"/>
+          <p:cNvSpPr/>
+          <p:nvPr/>
+        </p:nvSpPr>
+        <p:spPr>
+          <a:xfrm>
+            <a:off x="0" y="502920"/>
+            <a:ext cx="12192000" cy="45720"/>
+          </a:xfrm>
+          <a:prstGeom prst="rect">
+            <a:avLst/>
+          </a:prstGeom>
+          <a:solidFill>
+            <a:srgbClr val="BEAAFF"/>
+          </a:solidFill>
+          <a:ln>
+            <a:noFill/>
+          </a:ln>
+        </p:spPr>
+      </p:sp>
+      <p:sp>
+        <p:nvSpPr>
+          <p:cNvPr id="4" name="Deck kicker"/>
+          <p:cNvSpPr txBox="1"/>
+          <p:nvPr/>
+        </p:nvSpPr>
+        <p:spPr>
+          <a:xfrm>
+            <a:off x="685800" y="0"/>
+            <a:ext cx="8400000" cy="502920"/>
           </a:xfrm>
           <a:prstGeom prst="rect">
             <a:avLst/>
@@ -3286,45 +3794,74 @@
               </a:spcAft>
             </a:pPr>
             <a:r>
-              <a:rPr lang="en-US" sz="2400" b="1">
-                <a:solidFill>
-                  <a:srgbClr val="F4F5FF"/>
-                </a:solidFill>
-              </a:rPr>
-              <a:t>Sources.</a:t>
-            </a:r>
-            <a:r>
-              <a:rPr lang="en-US" sz="2400" b="1">
-                <a:solidFill>
-                  <a:srgbClr val="9D6CFF"/>
-                </a:solidFill>
-              </a:rPr>
-              <a:t> Every claim traces to one.</a:t>
-            </a:r>
-          </a:p>
-        </p:txBody>
-      </p:sp>
-      <p:sp>
-        <p:nvSpPr>
-          <p:cNvPr id="4" name="Sources"/>
-          <p:cNvSpPr txBox="1"/>
-          <p:nvPr/>
-        </p:nvSpPr>
-        <p:spPr>
-          <a:xfrm>
-            <a:off x="685800" y="1700000"/>
-            <a:ext cx="10820400" cy="4300000"/>
-          </a:xfrm>
-          <a:prstGeom prst="rect">
-            <a:avLst/>
-          </a:prstGeom>
-          <a:noFill/>
-          <a:ln>
-            <a:noFill/>
-          </a:ln>
-        </p:spPr>
-        <p:txBody>
-          <a:bodyPr wrap="square" lIns="182880" tIns="91440" rIns="182880" bIns="91440" anchor="t">
+              <a:rPr lang="en-US" sz="1100" b="1" cap="all" spc="120">
+                <a:solidFill>
+                  <a:srgbClr val="FFFFFF"/>
+                </a:solidFill>
+              </a:rPr>
+              <a:t>Datadog for Claude Cowork</a:t>
+            </a:r>
+          </a:p>
+        </p:txBody>
+      </p:sp>
+      <p:sp>
+        <p:nvSpPr>
+          <p:cNvPr id="5" name="Slide number"/>
+          <p:cNvSpPr txBox="1"/>
+          <p:nvPr/>
+        </p:nvSpPr>
+        <p:spPr>
+          <a:xfrm>
+            <a:off x="9100000" y="0"/>
+            <a:ext cx="2406400" cy="502920"/>
+          </a:xfrm>
+          <a:prstGeom prst="rect">
+            <a:avLst/>
+          </a:prstGeom>
+          <a:noFill/>
+          <a:ln>
+            <a:noFill/>
+          </a:ln>
+        </p:spPr>
+        <p:txBody>
+          <a:bodyPr wrap="square" lIns="182880" tIns="91440" rIns="182880" bIns="91440" anchor="ctr">
+            <a:normAutofit/>
+          </a:bodyPr>
+          <a:lstStyle/>
+          <a:p>
+            <a:pPr algn="r"/>
+            <a:r>
+              <a:rPr lang="en-US" sz="1100" b="1" cap="all" spc="120">
+                <a:solidFill>
+                  <a:srgbClr val="B8B8B8"/>
+                </a:solidFill>
+              </a:rPr>
+              <a:t>8 / 8</a:t>
+            </a:r>
+          </a:p>
+        </p:txBody>
+      </p:sp>
+      <p:sp>
+        <p:nvSpPr>
+          <p:cNvPr id="6" name="Title"/>
+          <p:cNvSpPr txBox="1"/>
+          <p:nvPr/>
+        </p:nvSpPr>
+        <p:spPr>
+          <a:xfrm>
+            <a:off x="685800" y="760000"/>
+            <a:ext cx="10820400" cy="1000000"/>
+          </a:xfrm>
+          <a:prstGeom prst="rect">
+            <a:avLst/>
+          </a:prstGeom>
+          <a:noFill/>
+          <a:ln>
+            <a:noFill/>
+          </a:ln>
+        </p:spPr>
+        <p:txBody>
+          <a:bodyPr wrap="square" lIns="182880" tIns="91440" rIns="182880" bIns="91440" anchor="ctr">
             <a:normAutofit/>
           </a:bodyPr>
           <a:lstStyle/>
@@ -3338,9 +3875,63 @@
               </a:spcAft>
             </a:pPr>
             <a:r>
+              <a:rPr lang="en-US" sz="2400" b="1">
+                <a:solidFill>
+                  <a:srgbClr val="000000"/>
+                </a:solidFill>
+                <a:latin typeface="+mj-lt"/>
+              </a:rPr>
+              <a:t>Sources.</a:t>
+            </a:r>
+            <a:r>
+              <a:rPr lang="en-US" sz="2400" b="1">
+                <a:solidFill>
+                  <a:srgbClr val="632CA6"/>
+                </a:solidFill>
+                <a:latin typeface="+mj-lt"/>
+              </a:rPr>
+              <a:t> Every claim traces to one.</a:t>
+            </a:r>
+          </a:p>
+        </p:txBody>
+      </p:sp>
+      <p:sp>
+        <p:nvSpPr>
+          <p:cNvPr id="7" name="Sources"/>
+          <p:cNvSpPr txBox="1"/>
+          <p:nvPr/>
+        </p:nvSpPr>
+        <p:spPr>
+          <a:xfrm>
+            <a:off x="685800" y="1900000"/>
+            <a:ext cx="10820400" cy="4300000"/>
+          </a:xfrm>
+          <a:prstGeom prst="rect">
+            <a:avLst/>
+          </a:prstGeom>
+          <a:noFill/>
+          <a:ln>
+            <a:noFill/>
+          </a:ln>
+        </p:spPr>
+        <p:txBody>
+          <a:bodyPr wrap="square" lIns="182880" tIns="91440" rIns="182880" bIns="91440" anchor="t">
+            <a:normAutofit/>
+          </a:bodyPr>
+          <a:lstStyle/>
+          <a:p>
+            <a:pPr algn="l">
+              <a:lnSpc>
+                <a:spcPct val="105000"/>
+              </a:lnSpc>
+              <a:spcAft>
+                <a:spcPts val="0"/>
+              </a:spcAft>
+            </a:pPr>
+            <a:r>
               <a:rPr lang="en-US" sz="1400" b="1">
                 <a:solidFill>
-                  <a:srgbClr val="F4F5FF"/>
+                  <a:srgbClr val="000000"/>
                 </a:solidFill>
               </a:rPr>
               <a:t>Datadog MCP Server</a:t>
@@ -3348,7 +3939,7 @@
             <a:r>
               <a:rPr lang="en-US" sz="1100">
                 <a:solidFill>
-                  <a:srgbClr val="B3B4BF"/>
+                  <a:srgbClr val="666666"/>
                 </a:solidFill>
               </a:rPr>
               <a:t>  retrieved 2026-09-29</a:t>
@@ -3366,7 +3957,7 @@
             <a:r>
               <a:rPr lang="en-US" sz="1100">
                 <a:solidFill>
-                  <a:srgbClr val="9D6CFF"/>
+                  <a:srgbClr val="632CA6"/>
                 </a:solidFill>
               </a:rPr>
               <a:t>https://docs.datadoghq.com/mcp_server/</a:t>
@@ -3384,7 +3975,7 @@
             <a:r>
               <a:rPr lang="en-US" sz="1400" b="1">
                 <a:solidFill>
-                  <a:srgbClr val="F4F5FF"/>
+                  <a:srgbClr val="000000"/>
                 </a:solidFill>
               </a:rPr>
               <a:t>Datadog Claude Code Plugin</a:t>
@@ -3392,7 +3983,7 @@
             <a:r>
               <a:rPr lang="en-US" sz="1100">
                 <a:solidFill>
-                  <a:srgbClr val="B3B4BF"/>
+                  <a:srgbClr val="666666"/>
                 </a:solidFill>
               </a:rPr>
               <a:t>  retrieved 2026-09-29</a:t>
@@ -3410,7 +4001,7 @@
             <a:r>
               <a:rPr lang="en-US" sz="1100">
                 <a:solidFill>
-                  <a:srgbClr val="9D6CFF"/>
+                  <a:srgbClr val="632CA6"/>
                 </a:solidFill>
               </a:rPr>
               <a:t>https://github.com/datadog-labs/claude-code-plugin</a:t>
@@ -3428,7 +4019,7 @@
             <a:r>
               <a:rPr lang="en-US" sz="1400" b="1">
                 <a:solidFill>
-                  <a:srgbClr val="F4F5FF"/>
+                  <a:srgbClr val="000000"/>
                 </a:solidFill>
               </a:rPr>
               <a:t>Datadog | Claude by Anthropic</a:t>
@@ -3436,7 +4027,7 @@
             <a:r>
               <a:rPr lang="en-US" sz="1100">
                 <a:solidFill>
-                  <a:srgbClr val="B3B4BF"/>
+                  <a:srgbClr val="666666"/>
                 </a:solidFill>
               </a:rPr>
               <a:t>  retrieved 2026-09-29</a:t>
@@ -3454,7 +4045,7 @@
             <a:r>
               <a:rPr lang="en-US" sz="1100">
                 <a:solidFill>
-                  <a:srgbClr val="9D6CFF"/>
+                  <a:srgbClr val="632CA6"/>
                 </a:solidFill>
               </a:rPr>
               <a:t>https://claude.com/marketplace/plugins/datadog</a:t>
@@ -3472,7 +4063,7 @@
             <a:r>
               <a:rPr lang="en-US" sz="1400" b="1">
                 <a:solidFill>
-                  <a:srgbClr val="F4F5FF"/>
+                  <a:srgbClr val="000000"/>
                 </a:solidFill>
               </a:rPr>
               <a:t>Set Up the Datadog MCP Server</a:t>
@@ -3480,7 +4071,7 @@
             <a:r>
               <a:rPr lang="en-US" sz="1100">
                 <a:solidFill>
-                  <a:srgbClr val="B3B4BF"/>
+                  <a:srgbClr val="666666"/>
                 </a:solidFill>
               </a:rPr>
               <a:t>  retrieved 2026-09-29</a:t>
@@ -3498,7 +4089,7 @@
             <a:r>
               <a:rPr lang="en-US" sz="1100">
                 <a:solidFill>
-                  <a:srgbClr val="9D6CFF"/>
+                  <a:srgbClr val="632CA6"/>
                 </a:solidFill>
               </a:rPr>
               <a:t>https://docs.datadoghq.com/mcp_server/setup/</a:t>
@@ -3508,14 +4099,14 @@
       </p:sp>
       <p:sp>
         <p:nvSpPr>
-          <p:cNvPr id="5" name="Footer"/>
+          <p:cNvPr id="8" name="Footer"/>
           <p:cNvSpPr txBox="1"/>
           <p:nvPr/>
         </p:nvSpPr>
         <p:spPr>
           <a:xfrm>
             <a:off x="685800" y="6250000"/>
-            <a:ext cx="9400000" cy="420000"/>
+            <a:ext cx="10820400" cy="420000"/>
           </a:xfrm>
           <a:prstGeom prst="rect">
             <a:avLst/>
@@ -3542,47 +4133,10 @@
             <a:r>
               <a:rPr lang="en-US" sz="1000">
                 <a:solidFill>
-                  <a:srgbClr val="B3B4BF"/>
-                </a:solidFill>
-              </a:rPr>
-              <a:t>datadog-cowork-plugin-2026-05-am-michael-kokoro-onnx</a:t>
-            </a:r>
-          </a:p>
-        </p:txBody>
-      </p:sp>
-      <p:sp>
-        <p:nvSpPr>
-          <p:cNvPr id="6" name="Slide number"/>
-          <p:cNvSpPr txBox="1"/>
-          <p:nvPr/>
-        </p:nvSpPr>
-        <p:spPr>
-          <a:xfrm>
-            <a:off x="10100000" y="6250000"/>
-            <a:ext cx="1400000" cy="420000"/>
-          </a:xfrm>
-          <a:prstGeom prst="rect">
-            <a:avLst/>
-          </a:prstGeom>
-          <a:noFill/>
-          <a:ln>
-            <a:noFill/>
-          </a:ln>
-        </p:spPr>
-        <p:txBody>
-          <a:bodyPr wrap="square" lIns="182880" tIns="91440" rIns="182880" bIns="91440" anchor="t">
-            <a:normAutofit/>
-          </a:bodyPr>
-          <a:lstStyle/>
-          <a:p>
-            <a:pPr algn="r"/>
-            <a:r>
-              <a:rPr lang="en-US" sz="1000">
-                <a:solidFill>
-                  <a:srgbClr val="B3B4BF"/>
-                </a:solidFill>
-              </a:rPr>
-              <a:t>8 / 8</a:t>
+                  <a:srgbClr val="666666"/>
+                </a:solidFill>
+              </a:rPr>
+              <a:t>datadog-cowork-plugin-2026-06-am-michael-kokoro-onnx</a:t>
             </a:r>
           </a:p>
         </p:txBody>
@@ -3596,59 +4150,59 @@
 </file>
 
 <file path=ppt/theme/theme1.xml><?xml version="1.0" encoding="utf-8"?>
-<a:theme xmlns:a="http://schemas.openxmlformats.org/drawingml/2006/main" name="datadog-dark">
+<a:theme xmlns:a="http://schemas.openxmlformats.org/drawingml/2006/main" name="datadog-cowork-plugin-brand">
   <a:themeElements>
-    <a:clrScheme name="datadog-dark">
+    <a:clrScheme name="datadog-cowork-plugin-brand">
       <a:dk1>
-        <a:srgbClr val="F4F5FF"/>
+        <a:srgbClr val="000000"/>
       </a:dk1>
       <a:lt1>
-        <a:srgbClr val="0B0D1A"/>
+        <a:srgbClr val="F8F6FB"/>
       </a:lt1>
       <a:dk2>
-        <a:srgbClr val="1F1F1F"/>
+        <a:srgbClr val="000000"/>
       </a:dk2>
       <a:lt2>
-        <a:srgbClr val="F8F8F8"/>
+        <a:srgbClr val="EFEAF6"/>
       </a:lt2>
       <a:accent1>
-        <a:srgbClr val="9D6CFF"/>
+        <a:srgbClr val="632CA6"/>
       </a:accent1>
       <a:accent2>
-        <a:srgbClr val="5B9BD5"/>
+        <a:srgbClr val="BEAAFF"/>
       </a:accent2>
       <a:accent3>
-        <a:srgbClr val="70AD47"/>
+        <a:srgbClr val="632CA6"/>
       </a:accent3>
       <a:accent4>
-        <a:srgbClr val="FFC000"/>
+        <a:srgbClr val="000000"/>
       </a:accent4>
       <a:accent5>
-        <a:srgbClr val="C00000"/>
+        <a:srgbClr val="666666"/>
       </a:accent5>
       <a:accent6>
-        <a:srgbClr val="7030A0"/>
+        <a:srgbClr val="B42318"/>
       </a:accent6>
       <a:hlink>
-        <a:srgbClr val="9D6CFF"/>
+        <a:srgbClr val="632CA6"/>
       </a:hlink>
       <a:folHlink>
-        <a:srgbClr val="7F7F7F"/>
+        <a:srgbClr val="666666"/>
       </a:folHlink>
     </a:clrScheme>
-    <a:fontScheme name="datadog-dark">
+    <a:fontScheme name="datadog-cowork-plugin-brand">
       <a:majorFont>
-        <a:latin typeface="Segoe UI"/>
+        <a:latin typeface="Noto Sans JP"/>
         <a:ea typeface=""/>
         <a:cs typeface=""/>
       </a:majorFont>
       <a:minorFont>
-        <a:latin typeface="Segoe UI"/>
+        <a:latin typeface="nationalweb"/>
         <a:ea typeface=""/>
         <a:cs typeface=""/>
       </a:minorFont>
     </a:fontScheme>
-    <a:fmtScheme name="datadog-dark">
+    <a:fmtScheme name="datadog-cowork-plugin-brand">
       <a:fillStyleLst>
         <a:solidFill>
           <a:schemeClr val="phClr"/>

</xml_diff>

<commit_message>
feat: regenerate datadog-cowork-plugin with stable Excalidraw strokes
- render four voices on media adapter 13; the diagram no longer boils at 3.75 Hz
- add video and spatial spectrograms and internal/external alignment evidence

🎨 - Generated by Copilot

Co-authored-by: Copilot <223556219+Copilot@users.noreply.github.com>
</commit_message>
<xml_diff>
--- a/projects/datadog-cowork-plugin/release/outputs/deck.pptx
+++ b/projects/datadog-cowork-plugin/release/outputs/deck.pptx
@@ -1582,7 +1582,7 @@
                   <a:srgbClr val="666666"/>
                 </a:solidFill>
               </a:rPr>
-              <a:t>datadog-cowork-plugin-2026-06-am-michael-kokoro-onnx</a:t>
+              <a:t>datadog-cowork-plugin-2026-07-am-michael-kokoro-onnx</a:t>
             </a:r>
           </a:p>
         </p:txBody>
@@ -4136,7 +4136,7 @@
                   <a:srgbClr val="666666"/>
                 </a:solidFill>
               </a:rPr>
-              <a:t>datadog-cowork-plugin-2026-06-am-michael-kokoro-onnx</a:t>
+              <a:t>datadog-cowork-plugin-2026-07-am-michael-kokoro-onnx</a:t>
             </a:r>
           </a:p>
         </p:txBody>

</xml_diff>